<commit_message>
Translate lecture materials to English
</commit_message>
<xml_diff>
--- a/DataStructuresAndAlgorithms/Lecture 03 - Linked Lists and Hash Table/Lecture 03 - Linked Lists and Hash Table.pptx
+++ b/DataStructuresAndAlgorithms/Lecture 03 - Linked Lists and Hash Table/Lecture 03 - Linked Lists and Hash Table.pptx
@@ -394,7 +394,7 @@
             <a:pPr indent="0" algn="r">
               <a:buNone/>
             </a:pPr>
-            <a:fld id="{06336D75-D809-4BA1-B28E-2B5D28A03790}" type="slidenum">
+            <a:fld id="{A7FF6FF9-CC6E-4727-ABDA-6ABD43231F87}" type="slidenum">
               <a:rPr b="0" lang="en-US" sz="1400" spc="-1" strike="noStrike">
                 <a:solidFill>
                   <a:srgbClr val="000000"/>
@@ -448,7 +448,7 @@
         <p:spPr>
           <a:xfrm>
             <a:off x="1376280" y="1336680"/>
-            <a:ext cx="4798440" cy="3598560"/>
+            <a:ext cx="4798080" cy="3598200"/>
           </a:xfrm>
           <a:prstGeom prst="rect">
             <a:avLst/>
@@ -471,7 +471,7 @@
         <p:spPr>
           <a:xfrm>
             <a:off x="756000" y="5145120"/>
-            <a:ext cx="6037920" cy="4200120"/>
+            <a:ext cx="6037560" cy="4199760"/>
           </a:xfrm>
           <a:prstGeom prst="rect">
             <a:avLst/>
@@ -507,7 +507,7 @@
         <p:spPr>
           <a:xfrm>
             <a:off x="0" y="10155240"/>
-            <a:ext cx="3266280" cy="526680"/>
+            <a:ext cx="3265920" cy="526320"/>
           </a:xfrm>
           <a:prstGeom prst="rect">
             <a:avLst/>
@@ -587,7 +587,7 @@
         <p:spPr>
           <a:xfrm>
             <a:off x="1376280" y="1336680"/>
-            <a:ext cx="4798440" cy="3598560"/>
+            <a:ext cx="4798080" cy="3598200"/>
           </a:xfrm>
           <a:prstGeom prst="rect">
             <a:avLst/>
@@ -610,7 +610,7 @@
         <p:spPr>
           <a:xfrm>
             <a:off x="756000" y="5145120"/>
-            <a:ext cx="6037920" cy="4200120"/>
+            <a:ext cx="6037560" cy="4199760"/>
           </a:xfrm>
           <a:prstGeom prst="rect">
             <a:avLst/>
@@ -646,7 +646,7 @@
         <p:spPr>
           <a:xfrm>
             <a:off x="0" y="10155240"/>
-            <a:ext cx="3266280" cy="526680"/>
+            <a:ext cx="3265920" cy="526320"/>
           </a:xfrm>
           <a:prstGeom prst="rect">
             <a:avLst/>
@@ -726,7 +726,7 @@
         <p:spPr>
           <a:xfrm>
             <a:off x="1376280" y="1336680"/>
-            <a:ext cx="4798440" cy="3598560"/>
+            <a:ext cx="4798080" cy="3598200"/>
           </a:xfrm>
           <a:prstGeom prst="rect">
             <a:avLst/>
@@ -749,7 +749,7 @@
         <p:spPr>
           <a:xfrm>
             <a:off x="756000" y="5145120"/>
-            <a:ext cx="6037920" cy="4200120"/>
+            <a:ext cx="6037560" cy="4199760"/>
           </a:xfrm>
           <a:prstGeom prst="rect">
             <a:avLst/>
@@ -785,7 +785,7 @@
         <p:spPr>
           <a:xfrm>
             <a:off x="0" y="10155240"/>
-            <a:ext cx="3266280" cy="526680"/>
+            <a:ext cx="3265920" cy="526320"/>
           </a:xfrm>
           <a:prstGeom prst="rect">
             <a:avLst/>
@@ -865,7 +865,7 @@
         <p:spPr>
           <a:xfrm>
             <a:off x="1376280" y="1336680"/>
-            <a:ext cx="4798440" cy="3598560"/>
+            <a:ext cx="4798080" cy="3598200"/>
           </a:xfrm>
           <a:prstGeom prst="rect">
             <a:avLst/>
@@ -888,7 +888,7 @@
         <p:spPr>
           <a:xfrm>
             <a:off x="756000" y="5145120"/>
-            <a:ext cx="6037920" cy="4200120"/>
+            <a:ext cx="6037560" cy="4199760"/>
           </a:xfrm>
           <a:prstGeom prst="rect">
             <a:avLst/>
@@ -924,7 +924,7 @@
         <p:spPr>
           <a:xfrm>
             <a:off x="0" y="10155240"/>
-            <a:ext cx="3266280" cy="526680"/>
+            <a:ext cx="3265920" cy="526320"/>
           </a:xfrm>
           <a:prstGeom prst="rect">
             <a:avLst/>
@@ -1004,7 +1004,7 @@
         <p:spPr>
           <a:xfrm>
             <a:off x="1376280" y="1336680"/>
-            <a:ext cx="4798440" cy="3598560"/>
+            <a:ext cx="4798080" cy="3598200"/>
           </a:xfrm>
           <a:prstGeom prst="rect">
             <a:avLst/>
@@ -1027,7 +1027,7 @@
         <p:spPr>
           <a:xfrm>
             <a:off x="756000" y="5145120"/>
-            <a:ext cx="6037920" cy="4200120"/>
+            <a:ext cx="6037560" cy="4199760"/>
           </a:xfrm>
           <a:prstGeom prst="rect">
             <a:avLst/>
@@ -1063,7 +1063,7 @@
         <p:spPr>
           <a:xfrm>
             <a:off x="0" y="10155240"/>
-            <a:ext cx="3266280" cy="526680"/>
+            <a:ext cx="3265920" cy="526320"/>
           </a:xfrm>
           <a:prstGeom prst="rect">
             <a:avLst/>
@@ -1143,7 +1143,7 @@
         <p:spPr>
           <a:xfrm>
             <a:off x="1376280" y="1336680"/>
-            <a:ext cx="4798440" cy="3598560"/>
+            <a:ext cx="4798080" cy="3598200"/>
           </a:xfrm>
           <a:prstGeom prst="rect">
             <a:avLst/>
@@ -1166,7 +1166,7 @@
         <p:spPr>
           <a:xfrm>
             <a:off x="756000" y="5145120"/>
-            <a:ext cx="6037920" cy="4200120"/>
+            <a:ext cx="6037560" cy="4199760"/>
           </a:xfrm>
           <a:prstGeom prst="rect">
             <a:avLst/>
@@ -1202,7 +1202,7 @@
         <p:spPr>
           <a:xfrm>
             <a:off x="0" y="10155240"/>
-            <a:ext cx="3266280" cy="526680"/>
+            <a:ext cx="3265920" cy="526320"/>
           </a:xfrm>
           <a:prstGeom prst="rect">
             <a:avLst/>
@@ -1282,7 +1282,7 @@
         <p:spPr>
           <a:xfrm>
             <a:off x="1376280" y="1336680"/>
-            <a:ext cx="4798440" cy="3598560"/>
+            <a:ext cx="4798080" cy="3598200"/>
           </a:xfrm>
           <a:prstGeom prst="rect">
             <a:avLst/>
@@ -1305,7 +1305,7 @@
         <p:spPr>
           <a:xfrm>
             <a:off x="756000" y="5145120"/>
-            <a:ext cx="6037920" cy="4200120"/>
+            <a:ext cx="6037560" cy="4199760"/>
           </a:xfrm>
           <a:prstGeom prst="rect">
             <a:avLst/>
@@ -1341,7 +1341,7 @@
         <p:spPr>
           <a:xfrm>
             <a:off x="0" y="10155240"/>
-            <a:ext cx="3266280" cy="526680"/>
+            <a:ext cx="3265920" cy="526320"/>
           </a:xfrm>
           <a:prstGeom prst="rect">
             <a:avLst/>
@@ -1421,7 +1421,7 @@
         <p:spPr>
           <a:xfrm>
             <a:off x="1376280" y="1336680"/>
-            <a:ext cx="4798440" cy="3598560"/>
+            <a:ext cx="4798080" cy="3598200"/>
           </a:xfrm>
           <a:prstGeom prst="rect">
             <a:avLst/>
@@ -1444,7 +1444,7 @@
         <p:spPr>
           <a:xfrm>
             <a:off x="756000" y="5145120"/>
-            <a:ext cx="6037920" cy="4200120"/>
+            <a:ext cx="6037560" cy="4199760"/>
           </a:xfrm>
           <a:prstGeom prst="rect">
             <a:avLst/>
@@ -1480,7 +1480,7 @@
         <p:spPr>
           <a:xfrm>
             <a:off x="0" y="10155240"/>
-            <a:ext cx="3266280" cy="526680"/>
+            <a:ext cx="3265920" cy="526320"/>
           </a:xfrm>
           <a:prstGeom prst="rect">
             <a:avLst/>
@@ -1560,7 +1560,7 @@
         <p:spPr>
           <a:xfrm>
             <a:off x="1376280" y="1336680"/>
-            <a:ext cx="4798440" cy="3598560"/>
+            <a:ext cx="4798080" cy="3598200"/>
           </a:xfrm>
           <a:prstGeom prst="rect">
             <a:avLst/>
@@ -1583,7 +1583,7 @@
         <p:spPr>
           <a:xfrm>
             <a:off x="756000" y="5145120"/>
-            <a:ext cx="6037920" cy="4200120"/>
+            <a:ext cx="6037560" cy="4199760"/>
           </a:xfrm>
           <a:prstGeom prst="rect">
             <a:avLst/>
@@ -1619,7 +1619,7 @@
         <p:spPr>
           <a:xfrm>
             <a:off x="0" y="10155240"/>
-            <a:ext cx="3266280" cy="526680"/>
+            <a:ext cx="3265920" cy="526320"/>
           </a:xfrm>
           <a:prstGeom prst="rect">
             <a:avLst/>
@@ -1699,7 +1699,7 @@
         <p:spPr>
           <a:xfrm>
             <a:off x="1376280" y="1336680"/>
-            <a:ext cx="4798440" cy="3598560"/>
+            <a:ext cx="4798080" cy="3598200"/>
           </a:xfrm>
           <a:prstGeom prst="rect">
             <a:avLst/>
@@ -1722,7 +1722,7 @@
         <p:spPr>
           <a:xfrm>
             <a:off x="756000" y="5145120"/>
-            <a:ext cx="6037920" cy="4200120"/>
+            <a:ext cx="6037560" cy="4199760"/>
           </a:xfrm>
           <a:prstGeom prst="rect">
             <a:avLst/>
@@ -1758,7 +1758,7 @@
         <p:spPr>
           <a:xfrm>
             <a:off x="0" y="10155240"/>
-            <a:ext cx="3266280" cy="526680"/>
+            <a:ext cx="3265920" cy="526320"/>
           </a:xfrm>
           <a:prstGeom prst="rect">
             <a:avLst/>
@@ -1838,7 +1838,7 @@
         <p:spPr>
           <a:xfrm>
             <a:off x="1376280" y="1336680"/>
-            <a:ext cx="4798440" cy="3598560"/>
+            <a:ext cx="4798080" cy="3598200"/>
           </a:xfrm>
           <a:prstGeom prst="rect">
             <a:avLst/>
@@ -1861,7 +1861,7 @@
         <p:spPr>
           <a:xfrm>
             <a:off x="756000" y="5145120"/>
-            <a:ext cx="6037920" cy="4200120"/>
+            <a:ext cx="6037560" cy="4199760"/>
           </a:xfrm>
           <a:prstGeom prst="rect">
             <a:avLst/>
@@ -1897,7 +1897,7 @@
         <p:spPr>
           <a:xfrm>
             <a:off x="0" y="10155240"/>
-            <a:ext cx="3266280" cy="526680"/>
+            <a:ext cx="3265920" cy="526320"/>
           </a:xfrm>
           <a:prstGeom prst="rect">
             <a:avLst/>
@@ -1977,7 +1977,7 @@
         <p:spPr>
           <a:xfrm>
             <a:off x="1376280" y="1336680"/>
-            <a:ext cx="4798440" cy="3598560"/>
+            <a:ext cx="4798080" cy="3598200"/>
           </a:xfrm>
           <a:prstGeom prst="rect">
             <a:avLst/>
@@ -2000,7 +2000,7 @@
         <p:spPr>
           <a:xfrm>
             <a:off x="756000" y="5145120"/>
-            <a:ext cx="6037920" cy="4200120"/>
+            <a:ext cx="6037560" cy="4199760"/>
           </a:xfrm>
           <a:prstGeom prst="rect">
             <a:avLst/>
@@ -2036,7 +2036,7 @@
         <p:spPr>
           <a:xfrm>
             <a:off x="0" y="10155240"/>
-            <a:ext cx="3266280" cy="526680"/>
+            <a:ext cx="3265920" cy="526320"/>
           </a:xfrm>
           <a:prstGeom prst="rect">
             <a:avLst/>
@@ -2116,7 +2116,7 @@
         <p:spPr>
           <a:xfrm>
             <a:off x="1376280" y="1336680"/>
-            <a:ext cx="4798440" cy="3598560"/>
+            <a:ext cx="4798080" cy="3598200"/>
           </a:xfrm>
           <a:prstGeom prst="rect">
             <a:avLst/>
@@ -2139,7 +2139,7 @@
         <p:spPr>
           <a:xfrm>
             <a:off x="756000" y="5145120"/>
-            <a:ext cx="6037920" cy="4200120"/>
+            <a:ext cx="6037560" cy="4199760"/>
           </a:xfrm>
           <a:prstGeom prst="rect">
             <a:avLst/>
@@ -2175,7 +2175,7 @@
         <p:spPr>
           <a:xfrm>
             <a:off x="0" y="10155240"/>
-            <a:ext cx="3266280" cy="526680"/>
+            <a:ext cx="3265920" cy="526320"/>
           </a:xfrm>
           <a:prstGeom prst="rect">
             <a:avLst/>
@@ -2255,7 +2255,7 @@
         <p:spPr>
           <a:xfrm>
             <a:off x="1376280" y="1336680"/>
-            <a:ext cx="4798440" cy="3598560"/>
+            <a:ext cx="4798080" cy="3598200"/>
           </a:xfrm>
           <a:prstGeom prst="rect">
             <a:avLst/>
@@ -2278,7 +2278,7 @@
         <p:spPr>
           <a:xfrm>
             <a:off x="756000" y="5145120"/>
-            <a:ext cx="6037920" cy="4200120"/>
+            <a:ext cx="6037560" cy="4199760"/>
           </a:xfrm>
           <a:prstGeom prst="rect">
             <a:avLst/>
@@ -2314,7 +2314,7 @@
         <p:spPr>
           <a:xfrm>
             <a:off x="0" y="10155240"/>
-            <a:ext cx="3266280" cy="526680"/>
+            <a:ext cx="3265920" cy="526320"/>
           </a:xfrm>
           <a:prstGeom prst="rect">
             <a:avLst/>
@@ -2394,7 +2394,7 @@
         <p:spPr>
           <a:xfrm>
             <a:off x="1376280" y="1336680"/>
-            <a:ext cx="4799520" cy="3599640"/>
+            <a:ext cx="4799160" cy="3599280"/>
           </a:xfrm>
           <a:prstGeom prst="rect">
             <a:avLst/>
@@ -2417,7 +2417,7 @@
         <p:spPr>
           <a:xfrm>
             <a:off x="756000" y="5145120"/>
-            <a:ext cx="6039000" cy="4201200"/>
+            <a:ext cx="6038640" cy="4200840"/>
           </a:xfrm>
           <a:prstGeom prst="rect">
             <a:avLst/>
@@ -2453,7 +2453,7 @@
         <p:spPr>
           <a:xfrm>
             <a:off x="0" y="10155240"/>
-            <a:ext cx="3267360" cy="527760"/>
+            <a:ext cx="3267000" cy="527400"/>
           </a:xfrm>
           <a:prstGeom prst="rect">
             <a:avLst/>
@@ -2533,7 +2533,7 @@
         <p:spPr>
           <a:xfrm>
             <a:off x="1376280" y="1336680"/>
-            <a:ext cx="4799520" cy="3599640"/>
+            <a:ext cx="4799160" cy="3599280"/>
           </a:xfrm>
           <a:prstGeom prst="rect">
             <a:avLst/>
@@ -2556,7 +2556,7 @@
         <p:spPr>
           <a:xfrm>
             <a:off x="756000" y="5145120"/>
-            <a:ext cx="6039000" cy="4201200"/>
+            <a:ext cx="6038640" cy="4200840"/>
           </a:xfrm>
           <a:prstGeom prst="rect">
             <a:avLst/>
@@ -2592,7 +2592,7 @@
         <p:spPr>
           <a:xfrm>
             <a:off x="0" y="10155240"/>
-            <a:ext cx="3267360" cy="527760"/>
+            <a:ext cx="3267000" cy="527400"/>
           </a:xfrm>
           <a:prstGeom prst="rect">
             <a:avLst/>
@@ -2672,7 +2672,7 @@
         <p:spPr>
           <a:xfrm>
             <a:off x="1376280" y="1336680"/>
-            <a:ext cx="4799520" cy="3599640"/>
+            <a:ext cx="4799160" cy="3599280"/>
           </a:xfrm>
           <a:prstGeom prst="rect">
             <a:avLst/>
@@ -2695,7 +2695,7 @@
         <p:spPr>
           <a:xfrm>
             <a:off x="756000" y="5145120"/>
-            <a:ext cx="6039000" cy="4201200"/>
+            <a:ext cx="6038640" cy="4200840"/>
           </a:xfrm>
           <a:prstGeom prst="rect">
             <a:avLst/>
@@ -2731,7 +2731,7 @@
         <p:spPr>
           <a:xfrm>
             <a:off x="0" y="10155240"/>
-            <a:ext cx="3267360" cy="527760"/>
+            <a:ext cx="3267000" cy="527400"/>
           </a:xfrm>
           <a:prstGeom prst="rect">
             <a:avLst/>
@@ -2811,7 +2811,7 @@
         <p:spPr>
           <a:xfrm>
             <a:off x="1376280" y="1336680"/>
-            <a:ext cx="4799520" cy="3599640"/>
+            <a:ext cx="4799160" cy="3599280"/>
           </a:xfrm>
           <a:prstGeom prst="rect">
             <a:avLst/>
@@ -2834,7 +2834,7 @@
         <p:spPr>
           <a:xfrm>
             <a:off x="756000" y="5145120"/>
-            <a:ext cx="6039000" cy="4201200"/>
+            <a:ext cx="6038640" cy="4200840"/>
           </a:xfrm>
           <a:prstGeom prst="rect">
             <a:avLst/>
@@ -2870,7 +2870,7 @@
         <p:spPr>
           <a:xfrm>
             <a:off x="0" y="10155240"/>
-            <a:ext cx="3267360" cy="527760"/>
+            <a:ext cx="3267000" cy="527400"/>
           </a:xfrm>
           <a:prstGeom prst="rect">
             <a:avLst/>
@@ -2950,7 +2950,7 @@
         <p:spPr>
           <a:xfrm>
             <a:off x="1376280" y="1336680"/>
-            <a:ext cx="4799520" cy="3599640"/>
+            <a:ext cx="4799160" cy="3599280"/>
           </a:xfrm>
           <a:prstGeom prst="rect">
             <a:avLst/>
@@ -2973,7 +2973,7 @@
         <p:spPr>
           <a:xfrm>
             <a:off x="756000" y="5145120"/>
-            <a:ext cx="6039000" cy="4201200"/>
+            <a:ext cx="6038640" cy="4200840"/>
           </a:xfrm>
           <a:prstGeom prst="rect">
             <a:avLst/>
@@ -3009,7 +3009,7 @@
         <p:spPr>
           <a:xfrm>
             <a:off x="0" y="10155240"/>
-            <a:ext cx="3267360" cy="527760"/>
+            <a:ext cx="3267000" cy="527400"/>
           </a:xfrm>
           <a:prstGeom prst="rect">
             <a:avLst/>
@@ -3089,7 +3089,7 @@
         <p:spPr>
           <a:xfrm>
             <a:off x="1376280" y="1336680"/>
-            <a:ext cx="4799520" cy="3599640"/>
+            <a:ext cx="4799160" cy="3599280"/>
           </a:xfrm>
           <a:prstGeom prst="rect">
             <a:avLst/>
@@ -3112,7 +3112,7 @@
         <p:spPr>
           <a:xfrm>
             <a:off x="756000" y="5145120"/>
-            <a:ext cx="6039000" cy="4201200"/>
+            <a:ext cx="6038640" cy="4200840"/>
           </a:xfrm>
           <a:prstGeom prst="rect">
             <a:avLst/>
@@ -3148,7 +3148,7 @@
         <p:spPr>
           <a:xfrm>
             <a:off x="0" y="10155240"/>
-            <a:ext cx="3267360" cy="527760"/>
+            <a:ext cx="3267000" cy="527400"/>
           </a:xfrm>
           <a:prstGeom prst="rect">
             <a:avLst/>
@@ -3228,7 +3228,7 @@
         <p:spPr>
           <a:xfrm>
             <a:off x="1376280" y="1336680"/>
-            <a:ext cx="4799520" cy="3599640"/>
+            <a:ext cx="4799160" cy="3599280"/>
           </a:xfrm>
           <a:prstGeom prst="rect">
             <a:avLst/>
@@ -3251,7 +3251,7 @@
         <p:spPr>
           <a:xfrm>
             <a:off x="756000" y="5145120"/>
-            <a:ext cx="6039000" cy="4201200"/>
+            <a:ext cx="6038640" cy="4200840"/>
           </a:xfrm>
           <a:prstGeom prst="rect">
             <a:avLst/>
@@ -3287,7 +3287,7 @@
         <p:spPr>
           <a:xfrm>
             <a:off x="0" y="10155240"/>
-            <a:ext cx="3267360" cy="527760"/>
+            <a:ext cx="3267000" cy="527400"/>
           </a:xfrm>
           <a:prstGeom prst="rect">
             <a:avLst/>
@@ -3367,7 +3367,7 @@
         <p:spPr>
           <a:xfrm>
             <a:off x="1376280" y="1336680"/>
-            <a:ext cx="4798440" cy="3598560"/>
+            <a:ext cx="4798080" cy="3598200"/>
           </a:xfrm>
           <a:prstGeom prst="rect">
             <a:avLst/>
@@ -3390,7 +3390,7 @@
         <p:spPr>
           <a:xfrm>
             <a:off x="756000" y="5145120"/>
-            <a:ext cx="6037920" cy="4200120"/>
+            <a:ext cx="6037560" cy="4199760"/>
           </a:xfrm>
           <a:prstGeom prst="rect">
             <a:avLst/>
@@ -3426,7 +3426,7 @@
         <p:spPr>
           <a:xfrm>
             <a:off x="0" y="10155240"/>
-            <a:ext cx="3266280" cy="526680"/>
+            <a:ext cx="3265920" cy="526320"/>
           </a:xfrm>
           <a:prstGeom prst="rect">
             <a:avLst/>
@@ -3506,7 +3506,7 @@
         <p:spPr>
           <a:xfrm>
             <a:off x="1376280" y="1336680"/>
-            <a:ext cx="4798440" cy="3598560"/>
+            <a:ext cx="4798080" cy="3598200"/>
           </a:xfrm>
           <a:prstGeom prst="rect">
             <a:avLst/>
@@ -3529,7 +3529,7 @@
         <p:spPr>
           <a:xfrm>
             <a:off x="756000" y="5145120"/>
-            <a:ext cx="6037920" cy="4200120"/>
+            <a:ext cx="6037560" cy="4199760"/>
           </a:xfrm>
           <a:prstGeom prst="rect">
             <a:avLst/>
@@ -3565,7 +3565,7 @@
         <p:spPr>
           <a:xfrm>
             <a:off x="0" y="10155240"/>
-            <a:ext cx="3266280" cy="526680"/>
+            <a:ext cx="3265920" cy="526320"/>
           </a:xfrm>
           <a:prstGeom prst="rect">
             <a:avLst/>
@@ -3645,7 +3645,7 @@
         <p:spPr>
           <a:xfrm>
             <a:off x="1376280" y="1336680"/>
-            <a:ext cx="4798440" cy="3598560"/>
+            <a:ext cx="4798080" cy="3598200"/>
           </a:xfrm>
           <a:prstGeom prst="rect">
             <a:avLst/>
@@ -3668,7 +3668,7 @@
         <p:spPr>
           <a:xfrm>
             <a:off x="756000" y="5145120"/>
-            <a:ext cx="6037920" cy="4200120"/>
+            <a:ext cx="6037560" cy="4199760"/>
           </a:xfrm>
           <a:prstGeom prst="rect">
             <a:avLst/>
@@ -3704,7 +3704,7 @@
         <p:spPr>
           <a:xfrm>
             <a:off x="0" y="10155240"/>
-            <a:ext cx="3266280" cy="526680"/>
+            <a:ext cx="3265920" cy="526320"/>
           </a:xfrm>
           <a:prstGeom prst="rect">
             <a:avLst/>
@@ -3784,7 +3784,7 @@
         <p:spPr>
           <a:xfrm>
             <a:off x="1376280" y="1336680"/>
-            <a:ext cx="4798440" cy="3598560"/>
+            <a:ext cx="4798080" cy="3598200"/>
           </a:xfrm>
           <a:prstGeom prst="rect">
             <a:avLst/>
@@ -3807,7 +3807,7 @@
         <p:spPr>
           <a:xfrm>
             <a:off x="756000" y="5145120"/>
-            <a:ext cx="6037920" cy="4200120"/>
+            <a:ext cx="6037560" cy="4199760"/>
           </a:xfrm>
           <a:prstGeom prst="rect">
             <a:avLst/>
@@ -3843,7 +3843,7 @@
         <p:spPr>
           <a:xfrm>
             <a:off x="0" y="10155240"/>
-            <a:ext cx="3266280" cy="526680"/>
+            <a:ext cx="3265920" cy="526320"/>
           </a:xfrm>
           <a:prstGeom prst="rect">
             <a:avLst/>
@@ -3923,7 +3923,7 @@
         <p:spPr>
           <a:xfrm>
             <a:off x="1376280" y="1336680"/>
-            <a:ext cx="4798440" cy="3598560"/>
+            <a:ext cx="4798080" cy="3598200"/>
           </a:xfrm>
           <a:prstGeom prst="rect">
             <a:avLst/>
@@ -3946,7 +3946,7 @@
         <p:spPr>
           <a:xfrm>
             <a:off x="756000" y="5145120"/>
-            <a:ext cx="6037920" cy="4200120"/>
+            <a:ext cx="6037560" cy="4199760"/>
           </a:xfrm>
           <a:prstGeom prst="rect">
             <a:avLst/>
@@ -3982,7 +3982,7 @@
         <p:spPr>
           <a:xfrm>
             <a:off x="0" y="10155240"/>
-            <a:ext cx="3266280" cy="526680"/>
+            <a:ext cx="3265920" cy="526320"/>
           </a:xfrm>
           <a:prstGeom prst="rect">
             <a:avLst/>
@@ -4062,7 +4062,7 @@
         <p:spPr>
           <a:xfrm>
             <a:off x="1376280" y="1336680"/>
-            <a:ext cx="4798440" cy="3598560"/>
+            <a:ext cx="4798080" cy="3598200"/>
           </a:xfrm>
           <a:prstGeom prst="rect">
             <a:avLst/>
@@ -4085,7 +4085,7 @@
         <p:spPr>
           <a:xfrm>
             <a:off x="756000" y="5145120"/>
-            <a:ext cx="6037920" cy="4200120"/>
+            <a:ext cx="6037560" cy="4199760"/>
           </a:xfrm>
           <a:prstGeom prst="rect">
             <a:avLst/>
@@ -4121,7 +4121,7 @@
         <p:spPr>
           <a:xfrm>
             <a:off x="0" y="10155240"/>
-            <a:ext cx="3266280" cy="526680"/>
+            <a:ext cx="3265920" cy="526320"/>
           </a:xfrm>
           <a:prstGeom prst="rect">
             <a:avLst/>
@@ -4201,7 +4201,7 @@
         <p:spPr>
           <a:xfrm>
             <a:off x="1376280" y="1336680"/>
-            <a:ext cx="4798440" cy="3598560"/>
+            <a:ext cx="4798080" cy="3598200"/>
           </a:xfrm>
           <a:prstGeom prst="rect">
             <a:avLst/>
@@ -4224,7 +4224,7 @@
         <p:spPr>
           <a:xfrm>
             <a:off x="756000" y="5145120"/>
-            <a:ext cx="6037920" cy="4200120"/>
+            <a:ext cx="6037560" cy="4199760"/>
           </a:xfrm>
           <a:prstGeom prst="rect">
             <a:avLst/>
@@ -4260,7 +4260,7 @@
         <p:spPr>
           <a:xfrm>
             <a:off x="0" y="10155240"/>
-            <a:ext cx="3266280" cy="526680"/>
+            <a:ext cx="3265920" cy="526320"/>
           </a:xfrm>
           <a:prstGeom prst="rect">
             <a:avLst/>
@@ -4340,7 +4340,7 @@
         <p:spPr>
           <a:xfrm>
             <a:off x="1376280" y="1336680"/>
-            <a:ext cx="4798440" cy="3598560"/>
+            <a:ext cx="4798080" cy="3598200"/>
           </a:xfrm>
           <a:prstGeom prst="rect">
             <a:avLst/>
@@ -4363,7 +4363,7 @@
         <p:spPr>
           <a:xfrm>
             <a:off x="756000" y="5145120"/>
-            <a:ext cx="6037920" cy="4200120"/>
+            <a:ext cx="6037560" cy="4199760"/>
           </a:xfrm>
           <a:prstGeom prst="rect">
             <a:avLst/>
@@ -4399,7 +4399,7 @@
         <p:spPr>
           <a:xfrm>
             <a:off x="0" y="10155240"/>
-            <a:ext cx="3266280" cy="526680"/>
+            <a:ext cx="3265920" cy="526320"/>
           </a:xfrm>
           <a:prstGeom prst="rect">
             <a:avLst/>
@@ -7452,7 +7452,7 @@
         <p:spPr>
           <a:xfrm>
             <a:off x="0" y="3150000"/>
-            <a:ext cx="9710280" cy="1250280"/>
+            <a:ext cx="9709920" cy="1249920"/>
           </a:xfrm>
           <a:prstGeom prst="rect">
             <a:avLst/>
@@ -8256,7 +8256,7 @@
         <p:spPr>
           <a:xfrm>
             <a:off x="0" y="3150000"/>
-            <a:ext cx="9710280" cy="1250280"/>
+            <a:ext cx="9709920" cy="1249920"/>
           </a:xfrm>
           <a:prstGeom prst="rect">
             <a:avLst/>
@@ -8336,7 +8336,7 @@
         <p:spPr>
           <a:xfrm>
             <a:off x="0" y="3150000"/>
-            <a:ext cx="9710280" cy="1250280"/>
+            <a:ext cx="9709920" cy="1249920"/>
           </a:xfrm>
           <a:prstGeom prst="rect">
             <a:avLst/>
@@ -9140,7 +9140,7 @@
         <p:spPr>
           <a:xfrm>
             <a:off x="0" y="3150000"/>
-            <a:ext cx="9710280" cy="1250280"/>
+            <a:ext cx="9709920" cy="1249920"/>
           </a:xfrm>
           <a:prstGeom prst="rect">
             <a:avLst/>
@@ -9944,7 +9944,7 @@
         <p:spPr>
           <a:xfrm>
             <a:off x="0" y="180000"/>
-            <a:ext cx="9710280" cy="1250280"/>
+            <a:ext cx="9709920" cy="1249920"/>
           </a:xfrm>
           <a:prstGeom prst="rect">
             <a:avLst/>
@@ -9991,7 +9991,7 @@
         <p:spPr>
           <a:xfrm>
             <a:off x="7560000" y="6840000"/>
-            <a:ext cx="2510280" cy="530280"/>
+            <a:ext cx="2509920" cy="529920"/>
           </a:xfrm>
           <a:prstGeom prst="rect">
             <a:avLst/>
@@ -10038,7 +10038,7 @@
         <p:spPr>
           <a:xfrm>
             <a:off x="900000" y="6840000"/>
-            <a:ext cx="6470280" cy="530280"/>
+            <a:ext cx="6469920" cy="529920"/>
           </a:xfrm>
           <a:prstGeom prst="rect">
             <a:avLst/>
@@ -10085,7 +10085,7 @@
         <p:spPr>
           <a:xfrm>
             <a:off x="180000" y="6840000"/>
-            <a:ext cx="530280" cy="530280"/>
+            <a:ext cx="529920" cy="529920"/>
           </a:xfrm>
           <a:prstGeom prst="rect">
             <a:avLst/>
@@ -10887,7 +10887,7 @@
         <p:spPr>
           <a:xfrm>
             <a:off x="0" y="180000"/>
-            <a:ext cx="9710280" cy="1250280"/>
+            <a:ext cx="9709920" cy="1249920"/>
           </a:xfrm>
           <a:prstGeom prst="rect">
             <a:avLst/>
@@ -10934,7 +10934,7 @@
         <p:spPr>
           <a:xfrm>
             <a:off x="7560000" y="6840000"/>
-            <a:ext cx="2510280" cy="530280"/>
+            <a:ext cx="2509920" cy="529920"/>
           </a:xfrm>
           <a:prstGeom prst="rect">
             <a:avLst/>
@@ -10981,7 +10981,7 @@
         <p:spPr>
           <a:xfrm>
             <a:off x="900000" y="6840000"/>
-            <a:ext cx="6470280" cy="530280"/>
+            <a:ext cx="6469920" cy="529920"/>
           </a:xfrm>
           <a:prstGeom prst="rect">
             <a:avLst/>
@@ -11028,7 +11028,7 @@
         <p:spPr>
           <a:xfrm>
             <a:off x="180000" y="6840000"/>
-            <a:ext cx="530280" cy="530280"/>
+            <a:ext cx="529920" cy="529920"/>
           </a:xfrm>
           <a:prstGeom prst="rect">
             <a:avLst/>
@@ -11380,7 +11380,7 @@
         <p:spPr>
           <a:xfrm>
             <a:off x="0" y="180000"/>
-            <a:ext cx="9710280" cy="1250280"/>
+            <a:ext cx="9709920" cy="1249920"/>
           </a:xfrm>
           <a:prstGeom prst="rect">
             <a:avLst/>
@@ -11427,7 +11427,7 @@
         <p:spPr>
           <a:xfrm>
             <a:off x="7560000" y="6840000"/>
-            <a:ext cx="2510280" cy="530280"/>
+            <a:ext cx="2509920" cy="529920"/>
           </a:xfrm>
           <a:prstGeom prst="rect">
             <a:avLst/>
@@ -11474,7 +11474,7 @@
         <p:spPr>
           <a:xfrm>
             <a:off x="900000" y="6840000"/>
-            <a:ext cx="6470280" cy="530280"/>
+            <a:ext cx="6469920" cy="529920"/>
           </a:xfrm>
           <a:prstGeom prst="rect">
             <a:avLst/>
@@ -11521,7 +11521,7 @@
         <p:spPr>
           <a:xfrm>
             <a:off x="180000" y="6840000"/>
-            <a:ext cx="530280" cy="530280"/>
+            <a:ext cx="529920" cy="529920"/>
           </a:xfrm>
           <a:prstGeom prst="rect">
             <a:avLst/>
@@ -12098,7 +12098,7 @@
         <p:spPr>
           <a:xfrm>
             <a:off x="0" y="180000"/>
-            <a:ext cx="9710280" cy="1250280"/>
+            <a:ext cx="9709920" cy="1249920"/>
           </a:xfrm>
           <a:prstGeom prst="rect">
             <a:avLst/>
@@ -12145,7 +12145,7 @@
         <p:spPr>
           <a:xfrm>
             <a:off x="7560000" y="6840000"/>
-            <a:ext cx="2510280" cy="530280"/>
+            <a:ext cx="2509920" cy="529920"/>
           </a:xfrm>
           <a:prstGeom prst="rect">
             <a:avLst/>
@@ -12192,7 +12192,7 @@
         <p:spPr>
           <a:xfrm>
             <a:off x="900000" y="6840000"/>
-            <a:ext cx="6470280" cy="530280"/>
+            <a:ext cx="6469920" cy="529920"/>
           </a:xfrm>
           <a:prstGeom prst="rect">
             <a:avLst/>
@@ -12239,7 +12239,7 @@
         <p:spPr>
           <a:xfrm>
             <a:off x="180000" y="6840000"/>
-            <a:ext cx="530280" cy="530280"/>
+            <a:ext cx="529920" cy="529920"/>
           </a:xfrm>
           <a:prstGeom prst="rect">
             <a:avLst/>
@@ -13266,7 +13266,7 @@
         <p:spPr>
           <a:xfrm>
             <a:off x="0" y="180000"/>
-            <a:ext cx="9710280" cy="1250280"/>
+            <a:ext cx="9709920" cy="1249920"/>
           </a:xfrm>
           <a:prstGeom prst="rect">
             <a:avLst/>
@@ -13313,7 +13313,7 @@
         <p:spPr>
           <a:xfrm>
             <a:off x="7560000" y="6840000"/>
-            <a:ext cx="2510280" cy="530280"/>
+            <a:ext cx="2509920" cy="529920"/>
           </a:xfrm>
           <a:prstGeom prst="rect">
             <a:avLst/>
@@ -13360,7 +13360,7 @@
         <p:spPr>
           <a:xfrm>
             <a:off x="900000" y="6840000"/>
-            <a:ext cx="6470280" cy="530280"/>
+            <a:ext cx="6469920" cy="529920"/>
           </a:xfrm>
           <a:prstGeom prst="rect">
             <a:avLst/>
@@ -13407,7 +13407,7 @@
         <p:spPr>
           <a:xfrm>
             <a:off x="180000" y="6840000"/>
-            <a:ext cx="530280" cy="530280"/>
+            <a:ext cx="529920" cy="529920"/>
           </a:xfrm>
           <a:prstGeom prst="rect">
             <a:avLst/>
@@ -13485,7 +13485,7 @@
         <p:spPr>
           <a:xfrm>
             <a:off x="0" y="180000"/>
-            <a:ext cx="9710280" cy="1250280"/>
+            <a:ext cx="9709920" cy="1249920"/>
           </a:xfrm>
           <a:prstGeom prst="rect">
             <a:avLst/>
@@ -13532,7 +13532,7 @@
         <p:spPr>
           <a:xfrm>
             <a:off x="7560000" y="6840000"/>
-            <a:ext cx="2510280" cy="530280"/>
+            <a:ext cx="2509920" cy="529920"/>
           </a:xfrm>
           <a:prstGeom prst="rect">
             <a:avLst/>
@@ -13579,7 +13579,7 @@
         <p:spPr>
           <a:xfrm>
             <a:off x="900000" y="6840000"/>
-            <a:ext cx="6470280" cy="530280"/>
+            <a:ext cx="6469920" cy="529920"/>
           </a:xfrm>
           <a:prstGeom prst="rect">
             <a:avLst/>
@@ -13626,7 +13626,7 @@
         <p:spPr>
           <a:xfrm>
             <a:off x="180000" y="6840000"/>
-            <a:ext cx="530280" cy="530280"/>
+            <a:ext cx="529920" cy="529920"/>
           </a:xfrm>
           <a:prstGeom prst="rect">
             <a:avLst/>
@@ -13978,7 +13978,7 @@
         <p:spPr>
           <a:xfrm>
             <a:off x="0" y="180000"/>
-            <a:ext cx="9710280" cy="1250280"/>
+            <a:ext cx="9709920" cy="1249920"/>
           </a:xfrm>
           <a:prstGeom prst="rect">
             <a:avLst/>
@@ -14025,7 +14025,7 @@
         <p:spPr>
           <a:xfrm>
             <a:off x="7560000" y="6840000"/>
-            <a:ext cx="2510280" cy="530280"/>
+            <a:ext cx="2509920" cy="529920"/>
           </a:xfrm>
           <a:prstGeom prst="rect">
             <a:avLst/>
@@ -14072,7 +14072,7 @@
         <p:spPr>
           <a:xfrm>
             <a:off x="900000" y="6840000"/>
-            <a:ext cx="6470280" cy="530280"/>
+            <a:ext cx="6469920" cy="529920"/>
           </a:xfrm>
           <a:prstGeom prst="rect">
             <a:avLst/>
@@ -14119,7 +14119,7 @@
         <p:spPr>
           <a:xfrm>
             <a:off x="180000" y="6840000"/>
-            <a:ext cx="530280" cy="530280"/>
+            <a:ext cx="529920" cy="529920"/>
           </a:xfrm>
           <a:prstGeom prst="rect">
             <a:avLst/>
@@ -14471,7 +14471,7 @@
         <p:spPr>
           <a:xfrm>
             <a:off x="0" y="3150000"/>
-            <a:ext cx="9710280" cy="1250280"/>
+            <a:ext cx="9709920" cy="1249920"/>
           </a:xfrm>
           <a:prstGeom prst="rect">
             <a:avLst/>
@@ -15050,7 +15050,7 @@
         <p:spPr>
           <a:xfrm>
             <a:off x="0" y="180000"/>
-            <a:ext cx="9710280" cy="1250280"/>
+            <a:ext cx="9709920" cy="1249920"/>
           </a:xfrm>
           <a:prstGeom prst="rect">
             <a:avLst/>
@@ -15097,7 +15097,7 @@
         <p:spPr>
           <a:xfrm>
             <a:off x="7560000" y="6840000"/>
-            <a:ext cx="2510280" cy="530280"/>
+            <a:ext cx="2509920" cy="529920"/>
           </a:xfrm>
           <a:prstGeom prst="rect">
             <a:avLst/>
@@ -15144,7 +15144,7 @@
         <p:spPr>
           <a:xfrm>
             <a:off x="900000" y="6840000"/>
-            <a:ext cx="6470280" cy="530280"/>
+            <a:ext cx="6469920" cy="529920"/>
           </a:xfrm>
           <a:prstGeom prst="rect">
             <a:avLst/>
@@ -15191,7 +15191,7 @@
         <p:spPr>
           <a:xfrm>
             <a:off x="180000" y="6840000"/>
-            <a:ext cx="530280" cy="530280"/>
+            <a:ext cx="529920" cy="529920"/>
           </a:xfrm>
           <a:prstGeom prst="rect">
             <a:avLst/>
@@ -15543,7 +15543,7 @@
         <p:spPr>
           <a:xfrm>
             <a:off x="0" y="180000"/>
-            <a:ext cx="9710280" cy="1250280"/>
+            <a:ext cx="9709920" cy="1249920"/>
           </a:xfrm>
           <a:prstGeom prst="rect">
             <a:avLst/>
@@ -15590,7 +15590,7 @@
         <p:spPr>
           <a:xfrm>
             <a:off x="7560000" y="6840000"/>
-            <a:ext cx="2510280" cy="530280"/>
+            <a:ext cx="2509920" cy="529920"/>
           </a:xfrm>
           <a:prstGeom prst="rect">
             <a:avLst/>
@@ -15637,7 +15637,7 @@
         <p:spPr>
           <a:xfrm>
             <a:off x="900000" y="6840000"/>
-            <a:ext cx="6470280" cy="530280"/>
+            <a:ext cx="6469920" cy="529920"/>
           </a:xfrm>
           <a:prstGeom prst="rect">
             <a:avLst/>
@@ -15684,7 +15684,7 @@
         <p:spPr>
           <a:xfrm>
             <a:off x="180000" y="6840000"/>
-            <a:ext cx="530280" cy="530280"/>
+            <a:ext cx="529920" cy="529920"/>
           </a:xfrm>
           <a:prstGeom prst="rect">
             <a:avLst/>
@@ -16261,7 +16261,7 @@
         <p:spPr>
           <a:xfrm>
             <a:off x="0" y="180000"/>
-            <a:ext cx="9710280" cy="1250280"/>
+            <a:ext cx="9709920" cy="1249920"/>
           </a:xfrm>
           <a:prstGeom prst="rect">
             <a:avLst/>
@@ -16308,7 +16308,7 @@
         <p:spPr>
           <a:xfrm>
             <a:off x="7560000" y="6840000"/>
-            <a:ext cx="2510280" cy="530280"/>
+            <a:ext cx="2509920" cy="529920"/>
           </a:xfrm>
           <a:prstGeom prst="rect">
             <a:avLst/>
@@ -16355,7 +16355,7 @@
         <p:spPr>
           <a:xfrm>
             <a:off x="900000" y="6840000"/>
-            <a:ext cx="6470280" cy="530280"/>
+            <a:ext cx="6469920" cy="529920"/>
           </a:xfrm>
           <a:prstGeom prst="rect">
             <a:avLst/>
@@ -16402,7 +16402,7 @@
         <p:spPr>
           <a:xfrm>
             <a:off x="180000" y="6840000"/>
-            <a:ext cx="530280" cy="530280"/>
+            <a:ext cx="529920" cy="529920"/>
           </a:xfrm>
           <a:prstGeom prst="rect">
             <a:avLst/>
@@ -16529,7 +16529,7 @@
         <p:spPr>
           <a:xfrm>
             <a:off x="0" y="180000"/>
-            <a:ext cx="9710280" cy="1250280"/>
+            <a:ext cx="9709920" cy="1249920"/>
           </a:xfrm>
           <a:prstGeom prst="rect">
             <a:avLst/>
@@ -16576,7 +16576,7 @@
         <p:spPr>
           <a:xfrm>
             <a:off x="7560000" y="6840000"/>
-            <a:ext cx="2510280" cy="530280"/>
+            <a:ext cx="2509920" cy="529920"/>
           </a:xfrm>
           <a:prstGeom prst="rect">
             <a:avLst/>
@@ -16623,7 +16623,7 @@
         <p:spPr>
           <a:xfrm>
             <a:off x="900000" y="6840000"/>
-            <a:ext cx="6470280" cy="530280"/>
+            <a:ext cx="6469920" cy="529920"/>
           </a:xfrm>
           <a:prstGeom prst="rect">
             <a:avLst/>
@@ -16670,7 +16670,7 @@
         <p:spPr>
           <a:xfrm>
             <a:off x="180000" y="6840000"/>
-            <a:ext cx="530280" cy="530280"/>
+            <a:ext cx="529920" cy="529920"/>
           </a:xfrm>
           <a:prstGeom prst="rect">
             <a:avLst/>
@@ -16748,7 +16748,7 @@
         <p:spPr>
           <a:xfrm>
             <a:off x="0" y="180000"/>
-            <a:ext cx="9710280" cy="1250280"/>
+            <a:ext cx="9709920" cy="1249920"/>
           </a:xfrm>
           <a:prstGeom prst="rect">
             <a:avLst/>
@@ -16795,7 +16795,7 @@
         <p:spPr>
           <a:xfrm>
             <a:off x="7560000" y="6840000"/>
-            <a:ext cx="2510280" cy="530280"/>
+            <a:ext cx="2509920" cy="529920"/>
           </a:xfrm>
           <a:prstGeom prst="rect">
             <a:avLst/>
@@ -16842,7 +16842,7 @@
         <p:spPr>
           <a:xfrm>
             <a:off x="900000" y="6840000"/>
-            <a:ext cx="6470280" cy="530280"/>
+            <a:ext cx="6469920" cy="529920"/>
           </a:xfrm>
           <a:prstGeom prst="rect">
             <a:avLst/>
@@ -16889,7 +16889,7 @@
         <p:spPr>
           <a:xfrm>
             <a:off x="180000" y="6840000"/>
-            <a:ext cx="530280" cy="530280"/>
+            <a:ext cx="529920" cy="529920"/>
           </a:xfrm>
           <a:prstGeom prst="rect">
             <a:avLst/>
@@ -17691,7 +17691,7 @@
         <p:spPr>
           <a:xfrm>
             <a:off x="0" y="180000"/>
-            <a:ext cx="9710280" cy="1250280"/>
+            <a:ext cx="9709920" cy="1249920"/>
           </a:xfrm>
           <a:prstGeom prst="rect">
             <a:avLst/>
@@ -17738,7 +17738,7 @@
         <p:spPr>
           <a:xfrm>
             <a:off x="7560000" y="6840000"/>
-            <a:ext cx="2510280" cy="530280"/>
+            <a:ext cx="2509920" cy="529920"/>
           </a:xfrm>
           <a:prstGeom prst="rect">
             <a:avLst/>
@@ -17785,7 +17785,7 @@
         <p:spPr>
           <a:xfrm>
             <a:off x="900000" y="6840000"/>
-            <a:ext cx="6470280" cy="530280"/>
+            <a:ext cx="6469920" cy="529920"/>
           </a:xfrm>
           <a:prstGeom prst="rect">
             <a:avLst/>
@@ -17832,7 +17832,7 @@
         <p:spPr>
           <a:xfrm>
             <a:off x="180000" y="6840000"/>
-            <a:ext cx="530280" cy="530280"/>
+            <a:ext cx="529920" cy="529920"/>
           </a:xfrm>
           <a:prstGeom prst="rect">
             <a:avLst/>
@@ -18634,7 +18634,7 @@
         <p:spPr>
           <a:xfrm>
             <a:off x="0" y="3150000"/>
-            <a:ext cx="9711360" cy="1251360"/>
+            <a:ext cx="9711000" cy="1251000"/>
           </a:xfrm>
           <a:prstGeom prst="rect">
             <a:avLst/>
@@ -18988,7 +18988,7 @@
         <p:spPr>
           <a:xfrm>
             <a:off x="0" y="180000"/>
-            <a:ext cx="9710280" cy="1250280"/>
+            <a:ext cx="9709920" cy="1249920"/>
           </a:xfrm>
           <a:prstGeom prst="rect">
             <a:avLst/>
@@ -19035,7 +19035,7 @@
         <p:spPr>
           <a:xfrm>
             <a:off x="7560000" y="6840000"/>
-            <a:ext cx="2510280" cy="530280"/>
+            <a:ext cx="2509920" cy="529920"/>
           </a:xfrm>
           <a:prstGeom prst="rect">
             <a:avLst/>
@@ -19082,7 +19082,7 @@
         <p:spPr>
           <a:xfrm>
             <a:off x="900000" y="6840000"/>
-            <a:ext cx="6470280" cy="530280"/>
+            <a:ext cx="6469920" cy="529920"/>
           </a:xfrm>
           <a:prstGeom prst="rect">
             <a:avLst/>
@@ -19129,7 +19129,7 @@
         <p:spPr>
           <a:xfrm>
             <a:off x="180000" y="6840000"/>
-            <a:ext cx="530280" cy="530280"/>
+            <a:ext cx="529920" cy="529920"/>
           </a:xfrm>
           <a:prstGeom prst="rect">
             <a:avLst/>
@@ -19481,7 +19481,7 @@
         <p:spPr>
           <a:xfrm>
             <a:off x="0" y="180000"/>
-            <a:ext cx="9710280" cy="1250280"/>
+            <a:ext cx="9709920" cy="1249920"/>
           </a:xfrm>
           <a:prstGeom prst="rect">
             <a:avLst/>
@@ -19528,7 +19528,7 @@
         <p:spPr>
           <a:xfrm>
             <a:off x="7560000" y="6840000"/>
-            <a:ext cx="2510280" cy="530280"/>
+            <a:ext cx="2509920" cy="529920"/>
           </a:xfrm>
           <a:prstGeom prst="rect">
             <a:avLst/>
@@ -19575,7 +19575,7 @@
         <p:spPr>
           <a:xfrm>
             <a:off x="900000" y="6840000"/>
-            <a:ext cx="6470280" cy="530280"/>
+            <a:ext cx="6469920" cy="529920"/>
           </a:xfrm>
           <a:prstGeom prst="rect">
             <a:avLst/>
@@ -19622,7 +19622,7 @@
         <p:spPr>
           <a:xfrm>
             <a:off x="180000" y="6840000"/>
-            <a:ext cx="530280" cy="530280"/>
+            <a:ext cx="529920" cy="529920"/>
           </a:xfrm>
           <a:prstGeom prst="rect">
             <a:avLst/>
@@ -19974,7 +19974,7 @@
         <p:spPr>
           <a:xfrm>
             <a:off x="0" y="3150000"/>
-            <a:ext cx="9710280" cy="1250280"/>
+            <a:ext cx="9709920" cy="1249920"/>
           </a:xfrm>
           <a:prstGeom prst="rect">
             <a:avLst/>
@@ -21003,7 +21003,7 @@
         <p:spPr>
           <a:xfrm>
             <a:off x="0" y="3150000"/>
-            <a:ext cx="9710280" cy="1250280"/>
+            <a:ext cx="9709920" cy="1249920"/>
           </a:xfrm>
           <a:prstGeom prst="rect">
             <a:avLst/>
@@ -21083,7 +21083,7 @@
         <p:spPr>
           <a:xfrm>
             <a:off x="0" y="3150000"/>
-            <a:ext cx="9710280" cy="1250280"/>
+            <a:ext cx="9709920" cy="1249920"/>
           </a:xfrm>
           <a:prstGeom prst="rect">
             <a:avLst/>
@@ -21159,7 +21159,34 @@
                 </a:solidFill>
                 <a:latin typeface="Arial"/>
               </a:rPr>
-              <a:t>Click to edit the title text format</a:t>
+              <a:t>Click to </a:t>
+            </a:r>
+            <a:r>
+              <a:rPr b="0" lang="en-US" sz="4400" spc="-1" strike="noStrike">
+                <a:solidFill>
+                  <a:srgbClr val="000000"/>
+                </a:solidFill>
+                <a:latin typeface="Arial"/>
+              </a:rPr>
+              <a:t>edit the </a:t>
+            </a:r>
+            <a:r>
+              <a:rPr b="0" lang="en-US" sz="4400" spc="-1" strike="noStrike">
+                <a:solidFill>
+                  <a:srgbClr val="000000"/>
+                </a:solidFill>
+                <a:latin typeface="Arial"/>
+              </a:rPr>
+              <a:t>title text </a:t>
+            </a:r>
+            <a:r>
+              <a:rPr b="0" lang="en-US" sz="4400" spc="-1" strike="noStrike">
+                <a:solidFill>
+                  <a:srgbClr val="000000"/>
+                </a:solidFill>
+                <a:latin typeface="Arial"/>
+              </a:rPr>
+              <a:t>format</a:t>
             </a:r>
             <a:endParaRPr b="0" lang="en-US" sz="4400" spc="-1" strike="noStrike">
               <a:solidFill>
@@ -21437,7 +21464,7 @@
         <p:spPr>
           <a:xfrm>
             <a:off x="0" y="3150000"/>
-            <a:ext cx="9710280" cy="1250280"/>
+            <a:ext cx="9709920" cy="1249920"/>
           </a:xfrm>
           <a:prstGeom prst="rect">
             <a:avLst/>
@@ -21791,7 +21818,7 @@
         <p:spPr>
           <a:xfrm>
             <a:off x="0" y="3150000"/>
-            <a:ext cx="9710280" cy="1250280"/>
+            <a:ext cx="9709920" cy="1249920"/>
           </a:xfrm>
           <a:prstGeom prst="rect">
             <a:avLst/>
@@ -22145,7 +22172,7 @@
         <p:spPr>
           <a:xfrm>
             <a:off x="0" y="3150000"/>
-            <a:ext cx="9710280" cy="1250280"/>
+            <a:ext cx="9709920" cy="1249920"/>
           </a:xfrm>
           <a:prstGeom prst="rect">
             <a:avLst/>
@@ -22724,7 +22751,7 @@
         <p:spPr>
           <a:xfrm>
             <a:off x="0" y="3150000"/>
-            <a:ext cx="9710280" cy="1250280"/>
+            <a:ext cx="9709920" cy="1249920"/>
           </a:xfrm>
           <a:prstGeom prst="rect">
             <a:avLst/>
@@ -22846,7 +22873,7 @@
         <p:spPr>
           <a:xfrm>
             <a:off x="360000" y="3330000"/>
-            <a:ext cx="9350280" cy="890280"/>
+            <a:ext cx="9349920" cy="889920"/>
           </a:xfrm>
           <a:prstGeom prst="rect">
             <a:avLst/>
@@ -22920,7 +22947,7 @@
         <p:spPr>
           <a:xfrm>
             <a:off x="540000" y="4680000"/>
-            <a:ext cx="9170280" cy="2510280"/>
+            <a:ext cx="9169920" cy="2509920"/>
           </a:xfrm>
           <a:prstGeom prst="rect">
             <a:avLst/>
@@ -23145,7 +23172,7 @@
         <p:spPr>
           <a:xfrm>
             <a:off x="360000" y="360000"/>
-            <a:ext cx="9350280" cy="890280"/>
+            <a:ext cx="9349920" cy="889920"/>
           </a:xfrm>
           <a:prstGeom prst="rect">
             <a:avLst/>
@@ -23199,7 +23226,7 @@
         <p:spPr>
           <a:xfrm>
             <a:off x="432000" y="1584000"/>
-            <a:ext cx="9170280" cy="4670280"/>
+            <a:ext cx="9169920" cy="4669920"/>
           </a:xfrm>
           <a:prstGeom prst="rect">
             <a:avLst/>
@@ -23342,7 +23369,7 @@
         <p:spPr>
           <a:xfrm>
             <a:off x="7608600" y="6886080"/>
-            <a:ext cx="2275560" cy="355320"/>
+            <a:ext cx="2275200" cy="354960"/>
           </a:xfrm>
           <a:prstGeom prst="rect">
             <a:avLst/>
@@ -23396,7 +23423,7 @@
         <p:spPr>
           <a:xfrm>
             <a:off x="897120" y="6886080"/>
-            <a:ext cx="6437520" cy="355320"/>
+            <a:ext cx="6437160" cy="354960"/>
           </a:xfrm>
           <a:prstGeom prst="rect">
             <a:avLst/>
@@ -23455,7 +23482,7 @@
         <p:spPr>
           <a:xfrm>
             <a:off x="1829160" y="2057400"/>
-            <a:ext cx="2055240" cy="684000"/>
+            <a:ext cx="2054880" cy="683640"/>
           </a:xfrm>
           <a:prstGeom prst="rect">
             <a:avLst/>
@@ -23478,7 +23505,7 @@
         <p:spPr>
           <a:xfrm>
             <a:off x="4572000" y="1657800"/>
-            <a:ext cx="4113360" cy="1376280"/>
+            <a:ext cx="4113000" cy="1375920"/>
           </a:xfrm>
           <a:prstGeom prst="rect">
             <a:avLst/>
@@ -23502,7 +23529,7 @@
         <p:spPr>
           <a:xfrm>
             <a:off x="1125360" y="5029560"/>
-            <a:ext cx="2759040" cy="455040"/>
+            <a:ext cx="2758680" cy="454680"/>
           </a:xfrm>
           <a:prstGeom prst="rect">
             <a:avLst/>
@@ -23525,7 +23552,7 @@
         <p:spPr>
           <a:xfrm>
             <a:off x="4048200" y="3200400"/>
-            <a:ext cx="5322960" cy="2971800"/>
+            <a:ext cx="5322600" cy="2971440"/>
           </a:xfrm>
           <a:prstGeom prst="rect">
             <a:avLst/>
@@ -23574,7 +23601,7 @@
         <p:spPr>
           <a:xfrm>
             <a:off x="360000" y="360000"/>
-            <a:ext cx="9350280" cy="890280"/>
+            <a:ext cx="9349920" cy="889920"/>
           </a:xfrm>
           <a:prstGeom prst="rect">
             <a:avLst/>
@@ -23628,7 +23655,7 @@
         <p:spPr>
           <a:xfrm>
             <a:off x="432000" y="1584000"/>
-            <a:ext cx="9170280" cy="4670280"/>
+            <a:ext cx="9169920" cy="4669920"/>
           </a:xfrm>
           <a:prstGeom prst="rect">
             <a:avLst/>
@@ -23771,7 +23798,7 @@
         <p:spPr>
           <a:xfrm>
             <a:off x="7608600" y="6886080"/>
-            <a:ext cx="2275560" cy="355320"/>
+            <a:ext cx="2275200" cy="354960"/>
           </a:xfrm>
           <a:prstGeom prst="rect">
             <a:avLst/>
@@ -23825,7 +23852,7 @@
         <p:spPr>
           <a:xfrm>
             <a:off x="897120" y="6886080"/>
-            <a:ext cx="6437520" cy="355320"/>
+            <a:ext cx="6437160" cy="354960"/>
           </a:xfrm>
           <a:prstGeom prst="rect">
             <a:avLst/>
@@ -23884,7 +23911,7 @@
         <p:spPr>
           <a:xfrm>
             <a:off x="668160" y="2514960"/>
-            <a:ext cx="2759040" cy="1598040"/>
+            <a:ext cx="2758680" cy="1597680"/>
           </a:xfrm>
           <a:prstGeom prst="rect">
             <a:avLst/>
@@ -23903,7 +23930,7 @@
         <p:spPr>
           <a:xfrm>
             <a:off x="457200" y="4114800"/>
-            <a:ext cx="3198960" cy="227160"/>
+            <a:ext cx="3198600" cy="226800"/>
           </a:xfrm>
           <a:prstGeom prst="rightArrow">
             <a:avLst>
@@ -23985,7 +24012,7 @@
         <p:spPr>
           <a:xfrm>
             <a:off x="360000" y="360000"/>
-            <a:ext cx="9350280" cy="890280"/>
+            <a:ext cx="9349920" cy="889920"/>
           </a:xfrm>
           <a:prstGeom prst="rect">
             <a:avLst/>
@@ -24039,7 +24066,7 @@
         <p:spPr>
           <a:xfrm>
             <a:off x="432000" y="1584000"/>
-            <a:ext cx="9170280" cy="4670280"/>
+            <a:ext cx="9169920" cy="4669920"/>
           </a:xfrm>
           <a:prstGeom prst="rect">
             <a:avLst/>
@@ -24182,7 +24209,7 @@
         <p:spPr>
           <a:xfrm>
             <a:off x="7608600" y="6886080"/>
-            <a:ext cx="2275560" cy="355320"/>
+            <a:ext cx="2275200" cy="354960"/>
           </a:xfrm>
           <a:prstGeom prst="rect">
             <a:avLst/>
@@ -24236,7 +24263,7 @@
         <p:spPr>
           <a:xfrm>
             <a:off x="897120" y="6886080"/>
-            <a:ext cx="6437520" cy="355320"/>
+            <a:ext cx="6437160" cy="354960"/>
           </a:xfrm>
           <a:prstGeom prst="rect">
             <a:avLst/>
@@ -24295,7 +24322,7 @@
         <p:spPr>
           <a:xfrm>
             <a:off x="668160" y="2514960"/>
-            <a:ext cx="2759040" cy="1598040"/>
+            <a:ext cx="2758680" cy="1597680"/>
           </a:xfrm>
           <a:prstGeom prst="rect">
             <a:avLst/>
@@ -24318,7 +24345,7 @@
         <p:spPr>
           <a:xfrm>
             <a:off x="4398480" y="2779200"/>
-            <a:ext cx="3829320" cy="1236240"/>
+            <a:ext cx="3828960" cy="1235880"/>
           </a:xfrm>
           <a:prstGeom prst="rect">
             <a:avLst/>
@@ -24337,7 +24364,7 @@
         <p:spPr>
           <a:xfrm>
             <a:off x="457560" y="4114800"/>
-            <a:ext cx="3198960" cy="227160"/>
+            <a:ext cx="3198600" cy="226800"/>
           </a:xfrm>
           <a:prstGeom prst="rightArrow">
             <a:avLst>
@@ -24419,7 +24446,7 @@
         <p:spPr>
           <a:xfrm>
             <a:off x="360000" y="360000"/>
-            <a:ext cx="9350280" cy="890280"/>
+            <a:ext cx="9349920" cy="889920"/>
           </a:xfrm>
           <a:prstGeom prst="rect">
             <a:avLst/>
@@ -24473,7 +24500,7 @@
         <p:spPr>
           <a:xfrm>
             <a:off x="432000" y="1584000"/>
-            <a:ext cx="9170280" cy="4670280"/>
+            <a:ext cx="9169920" cy="4669920"/>
           </a:xfrm>
           <a:prstGeom prst="rect">
             <a:avLst/>
@@ -24616,7 +24643,7 @@
         <p:spPr>
           <a:xfrm>
             <a:off x="7608600" y="6886080"/>
-            <a:ext cx="2275560" cy="355320"/>
+            <a:ext cx="2275200" cy="354960"/>
           </a:xfrm>
           <a:prstGeom prst="rect">
             <a:avLst/>
@@ -24670,7 +24697,7 @@
         <p:spPr>
           <a:xfrm>
             <a:off x="897120" y="6886080"/>
-            <a:ext cx="6437520" cy="355320"/>
+            <a:ext cx="6437160" cy="354960"/>
           </a:xfrm>
           <a:prstGeom prst="rect">
             <a:avLst/>
@@ -24729,7 +24756,7 @@
         <p:spPr>
           <a:xfrm>
             <a:off x="668160" y="1974960"/>
-            <a:ext cx="2759040" cy="1598040"/>
+            <a:ext cx="2758680" cy="1597680"/>
           </a:xfrm>
           <a:prstGeom prst="rect">
             <a:avLst/>
@@ -24778,7 +24805,7 @@
         <p:spPr>
           <a:xfrm>
             <a:off x="360000" y="360000"/>
-            <a:ext cx="9350280" cy="890280"/>
+            <a:ext cx="9349920" cy="889920"/>
           </a:xfrm>
           <a:prstGeom prst="rect">
             <a:avLst/>
@@ -24832,7 +24859,7 @@
         <p:spPr>
           <a:xfrm>
             <a:off x="432000" y="1584000"/>
-            <a:ext cx="9170280" cy="4670280"/>
+            <a:ext cx="9169920" cy="4669920"/>
           </a:xfrm>
           <a:prstGeom prst="rect">
             <a:avLst/>
@@ -25007,7 +25034,7 @@
         <p:spPr>
           <a:xfrm>
             <a:off x="7608600" y="6886080"/>
-            <a:ext cx="2275560" cy="355320"/>
+            <a:ext cx="2275200" cy="354960"/>
           </a:xfrm>
           <a:prstGeom prst="rect">
             <a:avLst/>
@@ -25061,7 +25088,7 @@
         <p:spPr>
           <a:xfrm>
             <a:off x="897120" y="6886080"/>
-            <a:ext cx="6437520" cy="355320"/>
+            <a:ext cx="6437160" cy="354960"/>
           </a:xfrm>
           <a:prstGeom prst="rect">
             <a:avLst/>
@@ -25114,12 +25141,13 @@
         </p:nvPicPr>
         <p:blipFill>
           <a:blip r:embed="rId1"/>
+          <a:srcRect l="0" t="17804" r="0" b="0"/>
           <a:stretch/>
         </p:blipFill>
         <p:spPr>
           <a:xfrm>
-            <a:off x="3600000" y="3429000"/>
-            <a:ext cx="6087960" cy="2567160"/>
+            <a:off x="3600000" y="3886200"/>
+            <a:ext cx="6087600" cy="2109600"/>
           </a:xfrm>
           <a:prstGeom prst="rect">
             <a:avLst/>
@@ -25142,7 +25170,7 @@
         <p:spPr>
           <a:xfrm>
             <a:off x="809280" y="2514600"/>
-            <a:ext cx="2618280" cy="1446120"/>
+            <a:ext cx="2617920" cy="1445760"/>
           </a:xfrm>
           <a:prstGeom prst="rect">
             <a:avLst/>
@@ -25191,7 +25219,7 @@
         <p:spPr>
           <a:xfrm>
             <a:off x="360000" y="360000"/>
-            <a:ext cx="9350280" cy="890280"/>
+            <a:ext cx="9349920" cy="889920"/>
           </a:xfrm>
           <a:prstGeom prst="rect">
             <a:avLst/>
@@ -25245,7 +25273,7 @@
         <p:spPr>
           <a:xfrm>
             <a:off x="360000" y="1980000"/>
-            <a:ext cx="9170280" cy="4670280"/>
+            <a:ext cx="9169920" cy="4669920"/>
           </a:xfrm>
           <a:prstGeom prst="rect">
             <a:avLst/>
@@ -25642,7 +25670,7 @@
         <p:spPr>
           <a:xfrm>
             <a:off x="7608600" y="6886080"/>
-            <a:ext cx="2275560" cy="355320"/>
+            <a:ext cx="2275200" cy="354960"/>
           </a:xfrm>
           <a:prstGeom prst="rect">
             <a:avLst/>
@@ -25696,7 +25724,7 @@
         <p:spPr>
           <a:xfrm>
             <a:off x="897120" y="6886080"/>
-            <a:ext cx="6437520" cy="355320"/>
+            <a:ext cx="6437160" cy="354960"/>
           </a:xfrm>
           <a:prstGeom prst="rect">
             <a:avLst/>
@@ -25754,7 +25782,7 @@
         <p:spPr>
           <a:xfrm>
             <a:off x="7560000" y="2816640"/>
-            <a:ext cx="1977120" cy="3660480"/>
+            <a:ext cx="1976760" cy="3660120"/>
           </a:xfrm>
           <a:prstGeom prst="rect">
             <a:avLst/>
@@ -25803,7 +25831,7 @@
         <p:spPr>
           <a:xfrm>
             <a:off x="360000" y="360000"/>
-            <a:ext cx="9350280" cy="890280"/>
+            <a:ext cx="9349920" cy="889920"/>
           </a:xfrm>
           <a:prstGeom prst="rect">
             <a:avLst/>
@@ -25857,7 +25885,7 @@
         <p:spPr>
           <a:xfrm>
             <a:off x="360000" y="1980000"/>
-            <a:ext cx="9170280" cy="4670280"/>
+            <a:ext cx="9169920" cy="4669920"/>
           </a:xfrm>
           <a:prstGeom prst="rect">
             <a:avLst/>
@@ -26190,7 +26218,7 @@
         <p:spPr>
           <a:xfrm>
             <a:off x="7608600" y="6886080"/>
-            <a:ext cx="2275560" cy="355320"/>
+            <a:ext cx="2275200" cy="354960"/>
           </a:xfrm>
           <a:prstGeom prst="rect">
             <a:avLst/>
@@ -26244,7 +26272,7 @@
         <p:spPr>
           <a:xfrm>
             <a:off x="897120" y="6886080"/>
-            <a:ext cx="6437520" cy="355320"/>
+            <a:ext cx="6437160" cy="354960"/>
           </a:xfrm>
           <a:prstGeom prst="rect">
             <a:avLst/>
@@ -26302,7 +26330,7 @@
         <p:spPr>
           <a:xfrm>
             <a:off x="7551000" y="2816640"/>
-            <a:ext cx="1977120" cy="3660480"/>
+            <a:ext cx="1976760" cy="3660120"/>
           </a:xfrm>
           <a:prstGeom prst="rect">
             <a:avLst/>
@@ -26325,7 +26353,7 @@
         <p:spPr>
           <a:xfrm>
             <a:off x="1600200" y="2914920"/>
-            <a:ext cx="3493800" cy="969840"/>
+            <a:ext cx="3493440" cy="969480"/>
           </a:xfrm>
           <a:prstGeom prst="rect">
             <a:avLst/>
@@ -26348,7 +26376,7 @@
         <p:spPr>
           <a:xfrm>
             <a:off x="1609920" y="4572000"/>
-            <a:ext cx="4332240" cy="2084040"/>
+            <a:ext cx="4331880" cy="2083680"/>
           </a:xfrm>
           <a:prstGeom prst="rect">
             <a:avLst/>
@@ -26371,7 +26399,7 @@
         <p:spPr>
           <a:xfrm>
             <a:off x="1600560" y="2914920"/>
-            <a:ext cx="3493800" cy="969840"/>
+            <a:ext cx="3493440" cy="969480"/>
           </a:xfrm>
           <a:prstGeom prst="rect">
             <a:avLst/>
@@ -26394,7 +26422,7 @@
         <p:spPr>
           <a:xfrm>
             <a:off x="1609920" y="4572360"/>
-            <a:ext cx="4332240" cy="2084040"/>
+            <a:ext cx="4331880" cy="2083680"/>
           </a:xfrm>
           <a:prstGeom prst="rect">
             <a:avLst/>
@@ -26443,7 +26471,7 @@
         <p:spPr>
           <a:xfrm>
             <a:off x="360000" y="360000"/>
-            <a:ext cx="9350280" cy="890280"/>
+            <a:ext cx="9349920" cy="889920"/>
           </a:xfrm>
           <a:prstGeom prst="rect">
             <a:avLst/>
@@ -26497,7 +26525,7 @@
         <p:spPr>
           <a:xfrm>
             <a:off x="360000" y="1980000"/>
-            <a:ext cx="9170280" cy="4670280"/>
+            <a:ext cx="9169920" cy="4669920"/>
           </a:xfrm>
           <a:prstGeom prst="rect">
             <a:avLst/>
@@ -26832,7 +26860,7 @@
         <p:spPr>
           <a:xfrm>
             <a:off x="7608600" y="6886080"/>
-            <a:ext cx="2275560" cy="355320"/>
+            <a:ext cx="2275200" cy="354960"/>
           </a:xfrm>
           <a:prstGeom prst="rect">
             <a:avLst/>
@@ -26886,7 +26914,7 @@
         <p:spPr>
           <a:xfrm>
             <a:off x="897120" y="6886080"/>
-            <a:ext cx="6437520" cy="355320"/>
+            <a:ext cx="6437160" cy="354960"/>
           </a:xfrm>
           <a:prstGeom prst="rect">
             <a:avLst/>
@@ -26944,7 +26972,7 @@
         <p:spPr>
           <a:xfrm>
             <a:off x="5433120" y="2053800"/>
-            <a:ext cx="4196880" cy="2320560"/>
+            <a:ext cx="4196520" cy="2320200"/>
           </a:xfrm>
           <a:prstGeom prst="rect">
             <a:avLst/>
@@ -26993,7 +27021,7 @@
         <p:spPr>
           <a:xfrm>
             <a:off x="360000" y="360000"/>
-            <a:ext cx="9350280" cy="890280"/>
+            <a:ext cx="9349920" cy="889920"/>
           </a:xfrm>
           <a:prstGeom prst="rect">
             <a:avLst/>
@@ -27047,7 +27075,7 @@
         <p:spPr>
           <a:xfrm>
             <a:off x="360000" y="1980000"/>
-            <a:ext cx="9170280" cy="4670280"/>
+            <a:ext cx="9169920" cy="4669920"/>
           </a:xfrm>
           <a:prstGeom prst="rect">
             <a:avLst/>
@@ -27302,7 +27330,7 @@
         <p:spPr>
           <a:xfrm>
             <a:off x="7608600" y="6886080"/>
-            <a:ext cx="2275560" cy="355320"/>
+            <a:ext cx="2275200" cy="354960"/>
           </a:xfrm>
           <a:prstGeom prst="rect">
             <a:avLst/>
@@ -27356,7 +27384,7 @@
         <p:spPr>
           <a:xfrm>
             <a:off x="897120" y="6886080"/>
-            <a:ext cx="6437520" cy="355320"/>
+            <a:ext cx="6437160" cy="354960"/>
           </a:xfrm>
           <a:prstGeom prst="rect">
             <a:avLst/>
@@ -27414,7 +27442,7 @@
         <p:spPr>
           <a:xfrm>
             <a:off x="5849640" y="457200"/>
-            <a:ext cx="3750120" cy="1950840"/>
+            <a:ext cx="3749760" cy="1950480"/>
           </a:xfrm>
           <a:prstGeom prst="rect">
             <a:avLst/>
@@ -27437,7 +27465,7 @@
         <p:spPr>
           <a:xfrm>
             <a:off x="4114800" y="1958760"/>
-            <a:ext cx="2587680" cy="2154600"/>
+            <a:ext cx="2587320" cy="2154240"/>
           </a:xfrm>
           <a:prstGeom prst="rect">
             <a:avLst/>
@@ -27460,7 +27488,7 @@
         <p:spPr>
           <a:xfrm>
             <a:off x="3886200" y="4343400"/>
-            <a:ext cx="3185640" cy="2284560"/>
+            <a:ext cx="3185280" cy="2284200"/>
           </a:xfrm>
           <a:prstGeom prst="rect">
             <a:avLst/>
@@ -27509,7 +27537,7 @@
         <p:spPr>
           <a:xfrm>
             <a:off x="360000" y="360000"/>
-            <a:ext cx="9350280" cy="890280"/>
+            <a:ext cx="9349920" cy="889920"/>
           </a:xfrm>
           <a:prstGeom prst="rect">
             <a:avLst/>
@@ -27563,7 +27591,7 @@
         <p:spPr>
           <a:xfrm>
             <a:off x="360000" y="1980000"/>
-            <a:ext cx="9170280" cy="4670280"/>
+            <a:ext cx="9169920" cy="4669920"/>
           </a:xfrm>
           <a:prstGeom prst="rect">
             <a:avLst/>
@@ -27866,7 +27894,7 @@
         <p:spPr>
           <a:xfrm>
             <a:off x="7608600" y="6886080"/>
-            <a:ext cx="2275560" cy="355320"/>
+            <a:ext cx="2275200" cy="354960"/>
           </a:xfrm>
           <a:prstGeom prst="rect">
             <a:avLst/>
@@ -27920,7 +27948,7 @@
         <p:spPr>
           <a:xfrm>
             <a:off x="897120" y="6886080"/>
-            <a:ext cx="6437520" cy="355320"/>
+            <a:ext cx="6437160" cy="354960"/>
           </a:xfrm>
           <a:prstGeom prst="rect">
             <a:avLst/>
@@ -27978,7 +28006,7 @@
         <p:spPr>
           <a:xfrm>
             <a:off x="4760280" y="1533960"/>
-            <a:ext cx="3696480" cy="1665000"/>
+            <a:ext cx="3696120" cy="1664640"/>
           </a:xfrm>
           <a:prstGeom prst="rect">
             <a:avLst/>
@@ -28001,7 +28029,7 @@
         <p:spPr>
           <a:xfrm>
             <a:off x="1479240" y="4321080"/>
-            <a:ext cx="2405520" cy="1849680"/>
+            <a:ext cx="2405160" cy="1849320"/>
           </a:xfrm>
           <a:prstGeom prst="rect">
             <a:avLst/>
@@ -28024,7 +28052,7 @@
         <p:spPr>
           <a:xfrm>
             <a:off x="4800600" y="4905720"/>
-            <a:ext cx="4417920" cy="1036440"/>
+            <a:ext cx="4417560" cy="1036080"/>
           </a:xfrm>
           <a:prstGeom prst="rect">
             <a:avLst/>
@@ -28073,7 +28101,7 @@
         <p:spPr>
           <a:xfrm>
             <a:off x="360000" y="360000"/>
-            <a:ext cx="9350280" cy="890280"/>
+            <a:ext cx="9349920" cy="889920"/>
           </a:xfrm>
           <a:prstGeom prst="rect">
             <a:avLst/>
@@ -28127,7 +28155,7 @@
         <p:spPr>
           <a:xfrm>
             <a:off x="360000" y="1980000"/>
-            <a:ext cx="9170280" cy="4670280"/>
+            <a:ext cx="9169920" cy="4669920"/>
           </a:xfrm>
           <a:prstGeom prst="rect">
             <a:avLst/>
@@ -28414,7 +28442,7 @@
         <p:spPr>
           <a:xfrm>
             <a:off x="7608600" y="6886080"/>
-            <a:ext cx="2275560" cy="355320"/>
+            <a:ext cx="2275200" cy="354960"/>
           </a:xfrm>
           <a:prstGeom prst="rect">
             <a:avLst/>
@@ -28468,7 +28496,7 @@
         <p:spPr>
           <a:xfrm>
             <a:off x="897120" y="6886080"/>
-            <a:ext cx="6437520" cy="355320"/>
+            <a:ext cx="6437160" cy="354960"/>
           </a:xfrm>
           <a:prstGeom prst="rect">
             <a:avLst/>
@@ -28552,7 +28580,7 @@
         <p:spPr>
           <a:xfrm>
             <a:off x="360000" y="360000"/>
-            <a:ext cx="9350280" cy="890280"/>
+            <a:ext cx="9349920" cy="889920"/>
           </a:xfrm>
           <a:prstGeom prst="rect">
             <a:avLst/>
@@ -28606,7 +28634,7 @@
         <p:spPr>
           <a:xfrm>
             <a:off x="457920" y="2514600"/>
-            <a:ext cx="5713200" cy="784080"/>
+            <a:ext cx="5712840" cy="783720"/>
           </a:xfrm>
           <a:prstGeom prst="rect">
             <a:avLst/>
@@ -28673,7 +28701,7 @@
         <p:spPr>
           <a:xfrm>
             <a:off x="360000" y="1980000"/>
-            <a:ext cx="9170280" cy="4670280"/>
+            <a:ext cx="9169920" cy="4669920"/>
           </a:xfrm>
           <a:prstGeom prst="rect">
             <a:avLst/>
@@ -28746,7 +28774,7 @@
         <p:spPr>
           <a:xfrm>
             <a:off x="7608600" y="6886080"/>
-            <a:ext cx="2275560" cy="355320"/>
+            <a:ext cx="2275200" cy="354960"/>
           </a:xfrm>
           <a:prstGeom prst="rect">
             <a:avLst/>
@@ -28800,7 +28828,7 @@
         <p:spPr>
           <a:xfrm>
             <a:off x="897120" y="6886080"/>
-            <a:ext cx="6437520" cy="355320"/>
+            <a:ext cx="6437160" cy="354960"/>
           </a:xfrm>
           <a:prstGeom prst="rect">
             <a:avLst/>
@@ -28884,7 +28912,7 @@
         <p:spPr>
           <a:xfrm>
             <a:off x="360000" y="360000"/>
-            <a:ext cx="9350280" cy="890280"/>
+            <a:ext cx="9349920" cy="889920"/>
           </a:xfrm>
           <a:prstGeom prst="rect">
             <a:avLst/>
@@ -28938,7 +28966,7 @@
         <p:spPr>
           <a:xfrm>
             <a:off x="7608600" y="6886080"/>
-            <a:ext cx="2275560" cy="355320"/>
+            <a:ext cx="2275200" cy="354960"/>
           </a:xfrm>
           <a:prstGeom prst="rect">
             <a:avLst/>
@@ -28992,7 +29020,7 @@
         <p:spPr>
           <a:xfrm>
             <a:off x="897120" y="6886080"/>
-            <a:ext cx="6437520" cy="355320"/>
+            <a:ext cx="6437160" cy="354960"/>
           </a:xfrm>
           <a:prstGeom prst="rect">
             <a:avLst/>
@@ -29046,7 +29074,7 @@
         <p:spPr>
           <a:xfrm>
             <a:off x="360000" y="1980000"/>
-            <a:ext cx="9170280" cy="4670280"/>
+            <a:ext cx="9169920" cy="4669920"/>
           </a:xfrm>
           <a:prstGeom prst="rect">
             <a:avLst/>
@@ -29283,7 +29311,7 @@
         <p:spPr>
           <a:xfrm>
             <a:off x="360000" y="3330000"/>
-            <a:ext cx="9351360" cy="891360"/>
+            <a:ext cx="9351000" cy="891000"/>
           </a:xfrm>
           <a:prstGeom prst="rect">
             <a:avLst/>
@@ -29367,7 +29395,7 @@
         <p:spPr>
           <a:xfrm>
             <a:off x="360000" y="360000"/>
-            <a:ext cx="9351360" cy="891360"/>
+            <a:ext cx="9351000" cy="891000"/>
           </a:xfrm>
           <a:prstGeom prst="rect">
             <a:avLst/>
@@ -29421,7 +29449,7 @@
         <p:spPr>
           <a:xfrm>
             <a:off x="7608600" y="6886080"/>
-            <a:ext cx="2276640" cy="356400"/>
+            <a:ext cx="2276280" cy="356040"/>
           </a:xfrm>
           <a:prstGeom prst="rect">
             <a:avLst/>
@@ -29475,7 +29503,7 @@
         <p:spPr>
           <a:xfrm>
             <a:off x="897120" y="6886080"/>
-            <a:ext cx="6438600" cy="356400"/>
+            <a:ext cx="6438240" cy="356040"/>
           </a:xfrm>
           <a:prstGeom prst="rect">
             <a:avLst/>
@@ -29529,7 +29557,7 @@
         <p:spPr>
           <a:xfrm>
             <a:off x="360000" y="1728000"/>
-            <a:ext cx="9171360" cy="4671360"/>
+            <a:ext cx="9171000" cy="4671000"/>
           </a:xfrm>
           <a:prstGeom prst="rect">
             <a:avLst/>
@@ -29910,7 +29938,7 @@
         <p:spPr>
           <a:xfrm>
             <a:off x="2057400" y="2286000"/>
-            <a:ext cx="5417280" cy="642600"/>
+            <a:ext cx="5416920" cy="642240"/>
           </a:xfrm>
           <a:prstGeom prst="rect">
             <a:avLst/>
@@ -29959,7 +29987,7 @@
         <p:spPr>
           <a:xfrm>
             <a:off x="360000" y="360000"/>
-            <a:ext cx="9351360" cy="891360"/>
+            <a:ext cx="9351000" cy="891000"/>
           </a:xfrm>
           <a:prstGeom prst="rect">
             <a:avLst/>
@@ -30013,7 +30041,7 @@
         <p:spPr>
           <a:xfrm>
             <a:off x="7608600" y="6886080"/>
-            <a:ext cx="2276640" cy="356400"/>
+            <a:ext cx="2276280" cy="356040"/>
           </a:xfrm>
           <a:prstGeom prst="rect">
             <a:avLst/>
@@ -30067,7 +30095,7 @@
         <p:spPr>
           <a:xfrm>
             <a:off x="897120" y="6886080"/>
-            <a:ext cx="6438600" cy="356400"/>
+            <a:ext cx="6438240" cy="356040"/>
           </a:xfrm>
           <a:prstGeom prst="rect">
             <a:avLst/>
@@ -30121,7 +30149,7 @@
         <p:spPr>
           <a:xfrm>
             <a:off x="360000" y="1980000"/>
-            <a:ext cx="9171360" cy="4671360"/>
+            <a:ext cx="9171000" cy="4671000"/>
           </a:xfrm>
           <a:prstGeom prst="rect">
             <a:avLst/>
@@ -30422,7 +30450,7 @@
         <p:spPr>
           <a:xfrm>
             <a:off x="1953000" y="3726000"/>
-            <a:ext cx="6273000" cy="1310400"/>
+            <a:ext cx="6272640" cy="1310040"/>
           </a:xfrm>
           <a:prstGeom prst="rect">
             <a:avLst/>
@@ -30445,7 +30473,7 @@
         <p:spPr>
           <a:xfrm>
             <a:off x="1962360" y="5696640"/>
-            <a:ext cx="2148840" cy="272160"/>
+            <a:ext cx="2148480" cy="271800"/>
           </a:xfrm>
           <a:prstGeom prst="rect">
             <a:avLst/>
@@ -30468,7 +30496,7 @@
         <p:spPr>
           <a:xfrm>
             <a:off x="2011680" y="6062400"/>
-            <a:ext cx="919800" cy="272160"/>
+            <a:ext cx="919440" cy="271800"/>
           </a:xfrm>
           <a:prstGeom prst="rect">
             <a:avLst/>
@@ -30491,7 +30519,7 @@
         <p:spPr>
           <a:xfrm>
             <a:off x="1975680" y="5036040"/>
-            <a:ext cx="5701680" cy="529560"/>
+            <a:ext cx="5701320" cy="529200"/>
           </a:xfrm>
           <a:prstGeom prst="rect">
             <a:avLst/>
@@ -30510,7 +30538,7 @@
         <p:spPr>
           <a:xfrm>
             <a:off x="6436080" y="4745160"/>
-            <a:ext cx="727920" cy="270720"/>
+            <a:ext cx="727560" cy="270360"/>
           </a:xfrm>
           <a:prstGeom prst="wedgeRoundRectCallout">
             <a:avLst>
@@ -30602,7 +30630,7 @@
         <p:spPr>
           <a:xfrm>
             <a:off x="360000" y="360000"/>
-            <a:ext cx="9351360" cy="891360"/>
+            <a:ext cx="9351000" cy="891000"/>
           </a:xfrm>
           <a:prstGeom prst="rect">
             <a:avLst/>
@@ -30656,7 +30684,7 @@
         <p:spPr>
           <a:xfrm>
             <a:off x="897120" y="6886080"/>
-            <a:ext cx="6438600" cy="356400"/>
+            <a:ext cx="6438240" cy="356040"/>
           </a:xfrm>
           <a:prstGeom prst="rect">
             <a:avLst/>
@@ -30710,7 +30738,7 @@
         <p:spPr>
           <a:xfrm>
             <a:off x="360000" y="1923480"/>
-            <a:ext cx="9171360" cy="4671360"/>
+            <a:ext cx="9171000" cy="4671000"/>
           </a:xfrm>
           <a:prstGeom prst="rect">
             <a:avLst/>
@@ -31043,7 +31071,7 @@
         <p:spPr>
           <a:xfrm>
             <a:off x="5833080" y="3340440"/>
-            <a:ext cx="3548880" cy="3168000"/>
+            <a:ext cx="3548520" cy="3167640"/>
           </a:xfrm>
           <a:prstGeom prst="rect">
             <a:avLst/>
@@ -31066,7 +31094,7 @@
         <p:spPr>
           <a:xfrm>
             <a:off x="546840" y="3780000"/>
-            <a:ext cx="4850280" cy="2728440"/>
+            <a:ext cx="4849920" cy="2728080"/>
           </a:xfrm>
           <a:prstGeom prst="rect">
             <a:avLst/>
@@ -31085,7 +31113,7 @@
         <p:spPr>
           <a:xfrm>
             <a:off x="7608600" y="6886080"/>
-            <a:ext cx="2276640" cy="356400"/>
+            <a:ext cx="2276280" cy="356040"/>
           </a:xfrm>
           <a:prstGeom prst="rect">
             <a:avLst/>
@@ -31169,7 +31197,7 @@
         <p:spPr>
           <a:xfrm>
             <a:off x="360000" y="360000"/>
-            <a:ext cx="9351360" cy="891360"/>
+            <a:ext cx="9351000" cy="891000"/>
           </a:xfrm>
           <a:prstGeom prst="rect">
             <a:avLst/>
@@ -31223,7 +31251,7 @@
         <p:spPr>
           <a:xfrm>
             <a:off x="7598520" y="6900480"/>
-            <a:ext cx="2276640" cy="356400"/>
+            <a:ext cx="2276280" cy="356040"/>
           </a:xfrm>
           <a:prstGeom prst="rect">
             <a:avLst/>
@@ -31277,7 +31305,7 @@
         <p:spPr>
           <a:xfrm>
             <a:off x="897120" y="6886080"/>
-            <a:ext cx="6438600" cy="356400"/>
+            <a:ext cx="6438240" cy="356040"/>
           </a:xfrm>
           <a:prstGeom prst="rect">
             <a:avLst/>
@@ -31331,7 +31359,7 @@
         <p:spPr>
           <a:xfrm>
             <a:off x="360000" y="1980000"/>
-            <a:ext cx="9171360" cy="4671360"/>
+            <a:ext cx="9171000" cy="4671000"/>
           </a:xfrm>
           <a:prstGeom prst="rect">
             <a:avLst/>
@@ -31654,7 +31682,7 @@
         <p:spPr>
           <a:xfrm>
             <a:off x="5754240" y="1980000"/>
-            <a:ext cx="2194920" cy="851040"/>
+            <a:ext cx="2194560" cy="850680"/>
           </a:xfrm>
           <a:prstGeom prst="rect">
             <a:avLst/>
@@ -31677,7 +31705,7 @@
         <p:spPr>
           <a:xfrm>
             <a:off x="5259960" y="3237840"/>
-            <a:ext cx="3948840" cy="2720160"/>
+            <a:ext cx="3948480" cy="2719800"/>
           </a:xfrm>
           <a:prstGeom prst="rect">
             <a:avLst/>
@@ -31726,7 +31754,7 @@
         <p:spPr>
           <a:xfrm>
             <a:off x="360000" y="360000"/>
-            <a:ext cx="9351360" cy="891360"/>
+            <a:ext cx="9351000" cy="891000"/>
           </a:xfrm>
           <a:prstGeom prst="rect">
             <a:avLst/>
@@ -31780,7 +31808,7 @@
         <p:spPr>
           <a:xfrm>
             <a:off x="7608600" y="6886080"/>
-            <a:ext cx="2276640" cy="356400"/>
+            <a:ext cx="2276280" cy="356040"/>
           </a:xfrm>
           <a:prstGeom prst="rect">
             <a:avLst/>
@@ -31834,7 +31862,7 @@
         <p:spPr>
           <a:xfrm>
             <a:off x="897120" y="6886080"/>
-            <a:ext cx="6438600" cy="356400"/>
+            <a:ext cx="6438240" cy="356040"/>
           </a:xfrm>
           <a:prstGeom prst="rect">
             <a:avLst/>
@@ -31888,7 +31916,7 @@
         <p:spPr>
           <a:xfrm>
             <a:off x="360000" y="1980000"/>
-            <a:ext cx="9171360" cy="4671360"/>
+            <a:ext cx="9171000" cy="4671000"/>
           </a:xfrm>
           <a:prstGeom prst="rect">
             <a:avLst/>
@@ -32163,7 +32191,7 @@
         <p:spPr>
           <a:xfrm>
             <a:off x="2080080" y="3547080"/>
-            <a:ext cx="6423480" cy="2573640"/>
+            <a:ext cx="6423120" cy="2573280"/>
           </a:xfrm>
           <a:prstGeom prst="rect">
             <a:avLst/>
@@ -32212,7 +32240,7 @@
         <p:spPr>
           <a:xfrm>
             <a:off x="360000" y="360000"/>
-            <a:ext cx="9351360" cy="891360"/>
+            <a:ext cx="9351000" cy="891000"/>
           </a:xfrm>
           <a:prstGeom prst="rect">
             <a:avLst/>
@@ -32266,7 +32294,7 @@
         <p:spPr>
           <a:xfrm>
             <a:off x="7608600" y="6886080"/>
-            <a:ext cx="2276640" cy="356400"/>
+            <a:ext cx="2276280" cy="356040"/>
           </a:xfrm>
           <a:prstGeom prst="rect">
             <a:avLst/>
@@ -32320,7 +32348,7 @@
         <p:spPr>
           <a:xfrm>
             <a:off x="897120" y="6886080"/>
-            <a:ext cx="6438600" cy="356400"/>
+            <a:ext cx="6438240" cy="356040"/>
           </a:xfrm>
           <a:prstGeom prst="rect">
             <a:avLst/>
@@ -32374,7 +32402,7 @@
         <p:spPr>
           <a:xfrm>
             <a:off x="360000" y="1980000"/>
-            <a:ext cx="9171360" cy="4671360"/>
+            <a:ext cx="9171000" cy="4671000"/>
           </a:xfrm>
           <a:prstGeom prst="rect">
             <a:avLst/>
@@ -32659,7 +32687,7 @@
         <p:spPr>
           <a:xfrm>
             <a:off x="360000" y="360000"/>
-            <a:ext cx="9350280" cy="890280"/>
+            <a:ext cx="9349920" cy="889920"/>
           </a:xfrm>
           <a:prstGeom prst="rect">
             <a:avLst/>
@@ -32713,7 +32741,7 @@
         <p:spPr>
           <a:xfrm>
             <a:off x="360000" y="1980000"/>
-            <a:ext cx="9170280" cy="4670280"/>
+            <a:ext cx="9169920" cy="4669920"/>
           </a:xfrm>
           <a:prstGeom prst="rect">
             <a:avLst/>
@@ -32834,7 +32862,7 @@
         <p:spPr>
           <a:xfrm>
             <a:off x="7608600" y="6886080"/>
-            <a:ext cx="2275560" cy="355320"/>
+            <a:ext cx="2275200" cy="354960"/>
           </a:xfrm>
           <a:prstGeom prst="rect">
             <a:avLst/>
@@ -32888,7 +32916,7 @@
         <p:spPr>
           <a:xfrm>
             <a:off x="897120" y="6886080"/>
-            <a:ext cx="6437520" cy="355320"/>
+            <a:ext cx="6437160" cy="354960"/>
           </a:xfrm>
           <a:prstGeom prst="rect">
             <a:avLst/>
@@ -32942,7 +32970,7 @@
         <p:spPr>
           <a:xfrm>
             <a:off x="458280" y="2514960"/>
-            <a:ext cx="5713200" cy="784080"/>
+            <a:ext cx="5712840" cy="783720"/>
           </a:xfrm>
           <a:prstGeom prst="rect">
             <a:avLst/>
@@ -33039,7 +33067,7 @@
         <p:spPr>
           <a:xfrm>
             <a:off x="360000" y="360000"/>
-            <a:ext cx="9350280" cy="890280"/>
+            <a:ext cx="9349920" cy="889920"/>
           </a:xfrm>
           <a:prstGeom prst="rect">
             <a:avLst/>
@@ -33093,7 +33121,7 @@
         <p:spPr>
           <a:xfrm>
             <a:off x="7608600" y="6886080"/>
-            <a:ext cx="2275560" cy="355320"/>
+            <a:ext cx="2275200" cy="354960"/>
           </a:xfrm>
           <a:prstGeom prst="rect">
             <a:avLst/>
@@ -33147,7 +33175,7 @@
         <p:spPr>
           <a:xfrm>
             <a:off x="897120" y="6886080"/>
-            <a:ext cx="6437520" cy="355320"/>
+            <a:ext cx="6437160" cy="354960"/>
           </a:xfrm>
           <a:prstGeom prst="rect">
             <a:avLst/>
@@ -33205,7 +33233,7 @@
         <p:spPr>
           <a:xfrm>
             <a:off x="205920" y="1474920"/>
-            <a:ext cx="9482040" cy="5082480"/>
+            <a:ext cx="9481680" cy="5082120"/>
           </a:xfrm>
           <a:prstGeom prst="rect">
             <a:avLst/>
@@ -33223,8 +33251,8 @@
         </p:nvSpPr>
         <p:spPr>
           <a:xfrm rot="8716800">
-            <a:off x="6568200" y="4603320"/>
-            <a:ext cx="798120" cy="336240"/>
+            <a:off x="6568560" y="4603320"/>
+            <a:ext cx="797760" cy="335880"/>
           </a:xfrm>
           <a:prstGeom prst="rightArrow">
             <a:avLst>
@@ -33306,7 +33334,7 @@
         <p:spPr>
           <a:xfrm>
             <a:off x="360000" y="360000"/>
-            <a:ext cx="9350280" cy="890280"/>
+            <a:ext cx="9349920" cy="889920"/>
           </a:xfrm>
           <a:prstGeom prst="rect">
             <a:avLst/>
@@ -33360,7 +33388,7 @@
         <p:spPr>
           <a:xfrm>
             <a:off x="360000" y="1980000"/>
-            <a:ext cx="9170280" cy="4670280"/>
+            <a:ext cx="9169920" cy="4669920"/>
           </a:xfrm>
           <a:prstGeom prst="rect">
             <a:avLst/>
@@ -33582,7 +33610,7 @@
         <p:spPr>
           <a:xfrm>
             <a:off x="7608600" y="6886080"/>
-            <a:ext cx="2275560" cy="355320"/>
+            <a:ext cx="2275200" cy="354960"/>
           </a:xfrm>
           <a:prstGeom prst="rect">
             <a:avLst/>
@@ -33636,7 +33664,7 @@
         <p:spPr>
           <a:xfrm>
             <a:off x="897120" y="6886080"/>
-            <a:ext cx="6437520" cy="355320"/>
+            <a:ext cx="6437160" cy="354960"/>
           </a:xfrm>
           <a:prstGeom prst="rect">
             <a:avLst/>
@@ -33720,7 +33748,7 @@
         <p:spPr>
           <a:xfrm>
             <a:off x="360000" y="360000"/>
-            <a:ext cx="9350280" cy="890280"/>
+            <a:ext cx="9349920" cy="889920"/>
           </a:xfrm>
           <a:prstGeom prst="rect">
             <a:avLst/>
@@ -33774,7 +33802,7 @@
         <p:spPr>
           <a:xfrm>
             <a:off x="360000" y="1980000"/>
-            <a:ext cx="9170280" cy="4670280"/>
+            <a:ext cx="9169920" cy="4669920"/>
           </a:xfrm>
           <a:prstGeom prst="rect">
             <a:avLst/>
@@ -34172,7 +34200,7 @@
         <p:spPr>
           <a:xfrm>
             <a:off x="7608600" y="6886080"/>
-            <a:ext cx="2275560" cy="355320"/>
+            <a:ext cx="2275200" cy="354960"/>
           </a:xfrm>
           <a:prstGeom prst="rect">
             <a:avLst/>
@@ -34231,7 +34259,7 @@
         <p:spPr>
           <a:xfrm>
             <a:off x="5258160" y="1711440"/>
-            <a:ext cx="4272120" cy="2630160"/>
+            <a:ext cx="4271760" cy="2629800"/>
           </a:xfrm>
           <a:prstGeom prst="rect">
             <a:avLst/>
@@ -34250,7 +34278,7 @@
         <p:spPr>
           <a:xfrm>
             <a:off x="897120" y="6886080"/>
-            <a:ext cx="6437520" cy="355320"/>
+            <a:ext cx="6437160" cy="354960"/>
           </a:xfrm>
           <a:prstGeom prst="rect">
             <a:avLst/>
@@ -34334,7 +34362,7 @@
         <p:spPr>
           <a:xfrm>
             <a:off x="360000" y="360000"/>
-            <a:ext cx="9350280" cy="890280"/>
+            <a:ext cx="9349920" cy="889920"/>
           </a:xfrm>
           <a:prstGeom prst="rect">
             <a:avLst/>
@@ -34388,7 +34416,7 @@
         <p:spPr>
           <a:xfrm>
             <a:off x="360000" y="1980000"/>
-            <a:ext cx="9170280" cy="4670280"/>
+            <a:ext cx="9169920" cy="4669920"/>
           </a:xfrm>
           <a:prstGeom prst="rect">
             <a:avLst/>
@@ -34840,7 +34868,7 @@
         <p:spPr>
           <a:xfrm>
             <a:off x="7608600" y="6886080"/>
-            <a:ext cx="2275560" cy="355320"/>
+            <a:ext cx="2275200" cy="354960"/>
           </a:xfrm>
           <a:prstGeom prst="rect">
             <a:avLst/>
@@ -34898,7 +34926,7 @@
         <p:spPr>
           <a:xfrm>
             <a:off x="5190840" y="3429000"/>
-            <a:ext cx="4339440" cy="2491560"/>
+            <a:ext cx="4339080" cy="2491200"/>
           </a:xfrm>
           <a:prstGeom prst="rect">
             <a:avLst/>
@@ -34917,7 +34945,7 @@
         <p:spPr>
           <a:xfrm>
             <a:off x="897120" y="6886080"/>
-            <a:ext cx="6437520" cy="355320"/>
+            <a:ext cx="6437160" cy="354960"/>
           </a:xfrm>
           <a:prstGeom prst="rect">
             <a:avLst/>
@@ -34975,7 +35003,7 @@
         <p:spPr>
           <a:xfrm>
             <a:off x="5029200" y="3429000"/>
-            <a:ext cx="4339440" cy="2491560"/>
+            <a:ext cx="4339080" cy="2491200"/>
           </a:xfrm>
           <a:prstGeom prst="rect">
             <a:avLst/>
@@ -35024,7 +35052,7 @@
         <p:spPr>
           <a:xfrm>
             <a:off x="360000" y="360000"/>
-            <a:ext cx="9350280" cy="890280"/>
+            <a:ext cx="9349920" cy="889920"/>
           </a:xfrm>
           <a:prstGeom prst="rect">
             <a:avLst/>
@@ -35078,7 +35106,7 @@
         <p:spPr>
           <a:xfrm>
             <a:off x="360000" y="1980000"/>
-            <a:ext cx="9170280" cy="4670280"/>
+            <a:ext cx="9169920" cy="4669920"/>
           </a:xfrm>
           <a:prstGeom prst="rect">
             <a:avLst/>
@@ -35269,7 +35297,7 @@
         <p:spPr>
           <a:xfrm>
             <a:off x="7608600" y="6886080"/>
-            <a:ext cx="2275560" cy="355320"/>
+            <a:ext cx="2275200" cy="354960"/>
           </a:xfrm>
           <a:prstGeom prst="rect">
             <a:avLst/>
@@ -35323,7 +35351,7 @@
         <p:spPr>
           <a:xfrm>
             <a:off x="897120" y="6886080"/>
-            <a:ext cx="6437520" cy="355320"/>
+            <a:ext cx="6437160" cy="354960"/>
           </a:xfrm>
           <a:prstGeom prst="rect">
             <a:avLst/>
@@ -35381,7 +35409,7 @@
         <p:spPr>
           <a:xfrm>
             <a:off x="2745360" y="3678840"/>
-            <a:ext cx="4796640" cy="2754000"/>
+            <a:ext cx="4796280" cy="2753640"/>
           </a:xfrm>
           <a:prstGeom prst="rect">
             <a:avLst/>
@@ -35430,7 +35458,7 @@
         <p:spPr>
           <a:xfrm>
             <a:off x="360000" y="360000"/>
-            <a:ext cx="9350280" cy="890280"/>
+            <a:ext cx="9349920" cy="889920"/>
           </a:xfrm>
           <a:prstGeom prst="rect">
             <a:avLst/>
@@ -35484,7 +35512,7 @@
         <p:spPr>
           <a:xfrm>
             <a:off x="7608600" y="6886080"/>
-            <a:ext cx="2275560" cy="355320"/>
+            <a:ext cx="2275200" cy="354960"/>
           </a:xfrm>
           <a:prstGeom prst="rect">
             <a:avLst/>
@@ -35538,7 +35566,7 @@
         <p:spPr>
           <a:xfrm>
             <a:off x="897120" y="6886080"/>
-            <a:ext cx="6437520" cy="355320"/>
+            <a:ext cx="6437160" cy="354960"/>
           </a:xfrm>
           <a:prstGeom prst="rect">
             <a:avLst/>
@@ -35596,7 +35624,7 @@
         <p:spPr>
           <a:xfrm>
             <a:off x="2286000" y="2057400"/>
-            <a:ext cx="5256000" cy="3673080"/>
+            <a:ext cx="5255640" cy="3672720"/>
           </a:xfrm>
           <a:prstGeom prst="rect">
             <a:avLst/>
@@ -35645,7 +35673,7 @@
         <p:spPr>
           <a:xfrm>
             <a:off x="360000" y="360000"/>
-            <a:ext cx="9350280" cy="890280"/>
+            <a:ext cx="9349920" cy="889920"/>
           </a:xfrm>
           <a:prstGeom prst="rect">
             <a:avLst/>
@@ -35699,7 +35727,7 @@
         <p:spPr>
           <a:xfrm>
             <a:off x="432000" y="1584000"/>
-            <a:ext cx="9170280" cy="4670280"/>
+            <a:ext cx="9169920" cy="4669920"/>
           </a:xfrm>
           <a:prstGeom prst="rect">
             <a:avLst/>
@@ -35842,7 +35870,7 @@
         <p:spPr>
           <a:xfrm>
             <a:off x="7608600" y="6886080"/>
-            <a:ext cx="2275560" cy="355320"/>
+            <a:ext cx="2275200" cy="354960"/>
           </a:xfrm>
           <a:prstGeom prst="rect">
             <a:avLst/>
@@ -35896,7 +35924,7 @@
         <p:spPr>
           <a:xfrm>
             <a:off x="897120" y="6886080"/>
-            <a:ext cx="6437520" cy="355320"/>
+            <a:ext cx="6437160" cy="354960"/>
           </a:xfrm>
           <a:prstGeom prst="rect">
             <a:avLst/>
@@ -35955,7 +35983,7 @@
         <p:spPr>
           <a:xfrm>
             <a:off x="1829160" y="2057400"/>
-            <a:ext cx="2055240" cy="684000"/>
+            <a:ext cx="2054880" cy="683640"/>
           </a:xfrm>
           <a:prstGeom prst="rect">
             <a:avLst/>
@@ -35978,7 +36006,7 @@
         <p:spPr>
           <a:xfrm>
             <a:off x="4572000" y="1657800"/>
-            <a:ext cx="3922200" cy="1312200"/>
+            <a:ext cx="3921840" cy="1311840"/>
           </a:xfrm>
           <a:prstGeom prst="rect">
             <a:avLst/>

</xml_diff>